<commit_message>
Rebuild the solution slide around the process-route modelling
The brief asks for two levers, input mix and energy source. Building the
process route as well is the part of the work that is ours rather than
the brief's, and the slide introducing the tool did not say so — it
described an extraction pipeline instead.

It now leads with what was added: 48 stages that switch out of the
route, 24 interchangeable technologies across the five stages that carry
real alternatives, a stage splittable between two technologies, and all
of it recomputing mid-drag. The screenshots are retaken on the neutral
starting profile, so nothing on the slide is site-specific.

Co-Authored-By: Claude Opus 5 <noreply@anthropic.com>
Claude-Session: https://claude.ai/code/session_01X3GMZtjGyiho7SGyEY7pGJ
</commit_message>
<xml_diff>
--- a/CarbonSpark_PS3.pptx
+++ b/CarbonSpark_PS3.pptx
@@ -682,7 +682,7 @@
           <a:p>
             <a:r>
               <a:rPr lang="en-US" dirty="0"/>
-              <a:t>This is the 'how'. Three things to land. First: the tool reads the workbook itself at load — no coefficient is re-typed, so it cannot drift from the source of truth. Second: the model is not a black box — every metric is linear in the virgin/scrap split, and the two transport rows are bilinear in (virgin/scrap) x (rail/road), which is what makes the whole thing exactly re-arrangeable. Third, the differentiator: because it is exactly re-arrangeable, we export the current route to the browser as a coefficient model, so while a slider is being dragged the figures AND the Plotly bars recompute in the page. Streamlit only commits a slider on release; without this the tool feels dead under the hand. The screenshot shows the docked Inputs panel — scrap ratio and haulage split — over the live readout.</a:t>
+              <a:t>This is the 'how', and the differentiation lives here — lead with it. The brief asks for two levers: input mix and energy source. We built those and then went further, modelling the process route itself, because the technology a stage runs moves the tonne as much as the charge does. Concretely: 48 stages that can each be switched out of the route, and 24 interchangeable technologies concentrated in five real decision points — six melting routes, four decarburisation, four refining, eight casting, two inspection. Pick two at one stage and the tonne splits between them, which is how a plant running two casters actually behaves. The second claim to land: all of it is live. Streamlit only commits a slider on release, so we re-arrange the route into a coefficient model and evaluate it in the page — figures and the charts move with your hand, and it still agrees with the server to 1e-9. The screenshot is the per-process table: every row carries its variation and its share, so nothing is hidden.</a:t>
             </a:r>
             <a:endParaRPr lang="en-US" dirty="0"/>
           </a:p>
@@ -2249,7 +2249,7 @@
                 <a:ea typeface="Cambria" pitchFamily="34" charset="-122"/>
                 <a:cs typeface="Cambria" pitchFamily="34" charset="-120"/>
               </a:rPr>
-              <a:t>CarbonSpark — the workbook, made interactive</a:t>
+              <a:t>CarbonSpark — every lever, live</a:t>
             </a:r>
             <a:endParaRPr lang="en-US" sz="2700" dirty="0"/>
           </a:p>
@@ -2264,7 +2264,7 @@
         <p:spPr>
           <a:xfrm>
             <a:off x="566928" y="1316736"/>
-            <a:ext cx="5623560" cy="694944"/>
+            <a:ext cx="5623560" cy="566928"/>
           </a:xfrm>
           <a:prstGeom prst="rect">
             <a:avLst/>
@@ -2291,7 +2291,7 @@
                 <a:ea typeface="Calibri" pitchFamily="34" charset="-122"/>
                 <a:cs typeface="Calibri" pitchFamily="34" charset="-120"/>
               </a:rPr>
-              <a:t>A Streamlit web application built directly on the supplied grid. Every coefficient is read from the workbook at load; nothing is re-typed, so the tool cannot drift from its source.</a:t>
+              <a:t>A web application built directly on the accounting grid. Every coefficient is read from the workbook at load, so the tool cannot drift from its source.</a:t>
             </a:r>
             <a:endParaRPr lang="en-US" sz="1250" dirty="0"/>
           </a:p>
@@ -2299,506 +2299,18 @@
       </p:sp>
       <p:sp>
         <p:nvSpPr>
-          <p:cNvPr id="6" name="Text 4"/>
-          <p:cNvSpPr txBox="1"/>
-          <p:nvPr/>
-        </p:nvSpPr>
-        <p:spPr>
-          <a:xfrm>
-            <a:off x="566928" y="2029968"/>
-            <a:ext cx="274320" cy="274320"/>
-          </a:xfrm>
-          <a:prstGeom prst="ellipse">
-            <a:avLst/>
-          </a:prstGeom>
-          <a:solidFill>
-            <a:srgbClr val="1F6E9E"/>
-          </a:solidFill>
-          <a:ln/>
-        </p:spPr>
-        <p:txBody>
-          <a:bodyPr wrap="square" lIns="0" tIns="0" rIns="0" bIns="0" rtlCol="0" anchor="ctr"/>
-          <a:lstStyle/>
-          <a:p>
-            <a:pPr algn="ctr" indent="0" marL="0">
-              <a:buNone/>
-            </a:pPr>
-            <a:r>
-              <a:rPr lang="en-US" sz="1000" b="1" dirty="0">
-                <a:solidFill>
-                  <a:srgbClr val="FFFFFF"/>
-                </a:solidFill>
-                <a:latin typeface="Calibri" pitchFamily="34" charset="0"/>
-                <a:ea typeface="Calibri" pitchFamily="34" charset="-122"/>
-                <a:cs typeface="Calibri" pitchFamily="34" charset="-120"/>
-              </a:rPr>
-              <a:t>1</a:t>
-            </a:r>
-            <a:endParaRPr lang="en-US" sz="1000" dirty="0"/>
-          </a:p>
-        </p:txBody>
-      </p:sp>
-      <p:sp>
-        <p:nvSpPr>
-          <p:cNvPr id="7" name="Text 5"/>
-          <p:cNvSpPr txBox="1"/>
-          <p:nvPr/>
-        </p:nvSpPr>
-        <p:spPr>
-          <a:xfrm>
-            <a:off x="969264" y="2002536"/>
-            <a:ext cx="5212080" cy="219456"/>
-          </a:xfrm>
-          <a:prstGeom prst="rect">
-            <a:avLst/>
-          </a:prstGeom>
-          <a:noFill/>
-          <a:ln/>
-        </p:spPr>
-        <p:txBody>
-          <a:bodyPr wrap="square" lIns="0" tIns="0" rIns="0" bIns="0" rtlCol="0" anchor="ctr"/>
-          <a:lstStyle/>
-          <a:p>
-            <a:pPr indent="0" marL="0">
-              <a:buNone/>
-            </a:pPr>
-            <a:r>
-              <a:rPr lang="en-US" sz="1200" b="1" dirty="0">
-                <a:solidFill>
-                  <a:srgbClr val="1F1F1E"/>
-                </a:solidFill>
-                <a:latin typeface="Calibri" pitchFamily="34" charset="0"/>
-                <a:ea typeface="Calibri" pitchFamily="34" charset="-122"/>
-                <a:cs typeface="Calibri" pitchFamily="34" charset="-120"/>
-              </a:rPr>
-              <a:t>Extract</a:t>
-            </a:r>
-            <a:endParaRPr lang="en-US" sz="1200" dirty="0"/>
-          </a:p>
-        </p:txBody>
-      </p:sp>
-      <p:sp>
-        <p:nvSpPr>
-          <p:cNvPr id="8" name="Text 6"/>
-          <p:cNvSpPr txBox="1"/>
-          <p:nvPr/>
-        </p:nvSpPr>
-        <p:spPr>
-          <a:xfrm>
-            <a:off x="969264" y="2212848"/>
-            <a:ext cx="5212080" cy="566928"/>
-          </a:xfrm>
-          <a:prstGeom prst="rect">
-            <a:avLst/>
-          </a:prstGeom>
-          <a:noFill/>
-          <a:ln/>
-        </p:spPr>
-        <p:txBody>
-          <a:bodyPr wrap="square" lIns="0" tIns="0" rIns="0" bIns="0" rtlCol="0" anchor="ctr"/>
-          <a:lstStyle/>
-          <a:p>
-            <a:pPr indent="0" marL="0">
-              <a:lnSpc>
-                <a:spcPts val="1400"/>
-              </a:lnSpc>
-              <a:buNone/>
-            </a:pPr>
-            <a:r>
-              <a:rPr lang="en-US" sz="1050" dirty="0">
-                <a:solidFill>
-                  <a:srgbClr val="5F5C55"/>
-                </a:solidFill>
-                <a:latin typeface="Calibri" pitchFamily="34" charset="0"/>
-                <a:ea typeface="Calibri" pitchFamily="34" charset="-122"/>
-                <a:cs typeface="Calibri" pitchFamily="34" charset="-120"/>
-              </a:rPr>
-              <a:t>67 process rows × 8 departments parsed from the workbook, coefficients and notes kept together.</a:t>
-            </a:r>
-            <a:endParaRPr lang="en-US" sz="1050" dirty="0"/>
-          </a:p>
-        </p:txBody>
-      </p:sp>
-      <p:sp>
-        <p:nvSpPr>
-          <p:cNvPr id="9" name="Text 7"/>
-          <p:cNvSpPr txBox="1"/>
-          <p:nvPr/>
-        </p:nvSpPr>
-        <p:spPr>
-          <a:xfrm>
-            <a:off x="566928" y="2999232"/>
-            <a:ext cx="274320" cy="274320"/>
-          </a:xfrm>
-          <a:prstGeom prst="ellipse">
-            <a:avLst/>
-          </a:prstGeom>
-          <a:solidFill>
-            <a:srgbClr val="1F6E9E"/>
-          </a:solidFill>
-          <a:ln/>
-        </p:spPr>
-        <p:txBody>
-          <a:bodyPr wrap="square" lIns="0" tIns="0" rIns="0" bIns="0" rtlCol="0" anchor="ctr"/>
-          <a:lstStyle/>
-          <a:p>
-            <a:pPr algn="ctr" indent="0" marL="0">
-              <a:buNone/>
-            </a:pPr>
-            <a:r>
-              <a:rPr lang="en-US" sz="1000" b="1" dirty="0">
-                <a:solidFill>
-                  <a:srgbClr val="FFFFFF"/>
-                </a:solidFill>
-                <a:latin typeface="Calibri" pitchFamily="34" charset="0"/>
-                <a:ea typeface="Calibri" pitchFamily="34" charset="-122"/>
-                <a:cs typeface="Calibri" pitchFamily="34" charset="-120"/>
-              </a:rPr>
-              <a:t>2</a:t>
-            </a:r>
-            <a:endParaRPr lang="en-US" sz="1000" dirty="0"/>
-          </a:p>
-        </p:txBody>
-      </p:sp>
-      <p:sp>
-        <p:nvSpPr>
-          <p:cNvPr id="10" name="Text 8"/>
-          <p:cNvSpPr txBox="1"/>
-          <p:nvPr/>
-        </p:nvSpPr>
-        <p:spPr>
-          <a:xfrm>
-            <a:off x="969264" y="2971800"/>
-            <a:ext cx="5212080" cy="219456"/>
-          </a:xfrm>
-          <a:prstGeom prst="rect">
-            <a:avLst/>
-          </a:prstGeom>
-          <a:noFill/>
-          <a:ln/>
-        </p:spPr>
-        <p:txBody>
-          <a:bodyPr wrap="square" lIns="0" tIns="0" rIns="0" bIns="0" rtlCol="0" anchor="ctr"/>
-          <a:lstStyle/>
-          <a:p>
-            <a:pPr indent="0" marL="0">
-              <a:buNone/>
-            </a:pPr>
-            <a:r>
-              <a:rPr lang="en-US" sz="1200" b="1" dirty="0">
-                <a:solidFill>
-                  <a:srgbClr val="1F1F1E"/>
-                </a:solidFill>
-                <a:latin typeface="Calibri" pitchFamily="34" charset="0"/>
-                <a:ea typeface="Calibri" pitchFamily="34" charset="-122"/>
-                <a:cs typeface="Calibri" pitchFamily="34" charset="-120"/>
-              </a:rPr>
-              <a:t>Model</a:t>
-            </a:r>
-            <a:endParaRPr lang="en-US" sz="1200" dirty="0"/>
-          </a:p>
-        </p:txBody>
-      </p:sp>
-      <p:sp>
-        <p:nvSpPr>
-          <p:cNvPr id="11" name="Text 9"/>
-          <p:cNvSpPr txBox="1"/>
-          <p:nvPr/>
-        </p:nvSpPr>
-        <p:spPr>
-          <a:xfrm>
-            <a:off x="969264" y="3182112"/>
-            <a:ext cx="5212080" cy="566928"/>
-          </a:xfrm>
-          <a:prstGeom prst="rect">
-            <a:avLst/>
-          </a:prstGeom>
-          <a:noFill/>
-          <a:ln/>
-        </p:spPr>
-        <p:txBody>
-          <a:bodyPr wrap="square" lIns="0" tIns="0" rIns="0" bIns="0" rtlCol="0" anchor="ctr"/>
-          <a:lstStyle/>
-          <a:p>
-            <a:pPr indent="0" marL="0">
-              <a:lnSpc>
-                <a:spcPts val="1400"/>
-              </a:lnSpc>
-              <a:buNone/>
-            </a:pPr>
-            <a:r>
-              <a:rPr lang="en-US" sz="1050" dirty="0">
-                <a:solidFill>
-                  <a:srgbClr val="5F5C55"/>
-                </a:solidFill>
-                <a:latin typeface="Calibri" pitchFamily="34" charset="0"/>
-                <a:ea typeface="Calibri" pitchFamily="34" charset="-122"/>
-                <a:cs typeface="Calibri" pitchFamily="34" charset="-120"/>
-              </a:rPr>
-              <a:t>Every metric is linear in virgin/scrap share; transport rows are bilinear in (x,y)×(rail,road). Scope 2 = kWh × grid factor.</a:t>
-            </a:r>
-            <a:endParaRPr lang="en-US" sz="1050" dirty="0"/>
-          </a:p>
-        </p:txBody>
-      </p:sp>
-      <p:sp>
-        <p:nvSpPr>
-          <p:cNvPr id="12" name="Text 10"/>
-          <p:cNvSpPr txBox="1"/>
-          <p:nvPr/>
-        </p:nvSpPr>
-        <p:spPr>
-          <a:xfrm>
-            <a:off x="566928" y="3968496"/>
-            <a:ext cx="274320" cy="274320"/>
-          </a:xfrm>
-          <a:prstGeom prst="ellipse">
-            <a:avLst/>
-          </a:prstGeom>
-          <a:solidFill>
-            <a:srgbClr val="1F6E9E"/>
-          </a:solidFill>
-          <a:ln/>
-        </p:spPr>
-        <p:txBody>
-          <a:bodyPr wrap="square" lIns="0" tIns="0" rIns="0" bIns="0" rtlCol="0" anchor="ctr"/>
-          <a:lstStyle/>
-          <a:p>
-            <a:pPr algn="ctr" indent="0" marL="0">
-              <a:buNone/>
-            </a:pPr>
-            <a:r>
-              <a:rPr lang="en-US" sz="1000" b="1" dirty="0">
-                <a:solidFill>
-                  <a:srgbClr val="FFFFFF"/>
-                </a:solidFill>
-                <a:latin typeface="Calibri" pitchFamily="34" charset="0"/>
-                <a:ea typeface="Calibri" pitchFamily="34" charset="-122"/>
-                <a:cs typeface="Calibri" pitchFamily="34" charset="-120"/>
-              </a:rPr>
-              <a:t>3</a:t>
-            </a:r>
-            <a:endParaRPr lang="en-US" sz="1000" dirty="0"/>
-          </a:p>
-        </p:txBody>
-      </p:sp>
-      <p:sp>
-        <p:nvSpPr>
-          <p:cNvPr id="13" name="Text 11"/>
-          <p:cNvSpPr txBox="1"/>
-          <p:nvPr/>
-        </p:nvSpPr>
-        <p:spPr>
-          <a:xfrm>
-            <a:off x="969264" y="3941064"/>
-            <a:ext cx="5212080" cy="219456"/>
-          </a:xfrm>
-          <a:prstGeom prst="rect">
-            <a:avLst/>
-          </a:prstGeom>
-          <a:noFill/>
-          <a:ln/>
-        </p:spPr>
-        <p:txBody>
-          <a:bodyPr wrap="square" lIns="0" tIns="0" rIns="0" bIns="0" rtlCol="0" anchor="ctr"/>
-          <a:lstStyle/>
-          <a:p>
-            <a:pPr indent="0" marL="0">
-              <a:buNone/>
-            </a:pPr>
-            <a:r>
-              <a:rPr lang="en-US" sz="1200" b="1" dirty="0">
-                <a:solidFill>
-                  <a:srgbClr val="1F1F1E"/>
-                </a:solidFill>
-                <a:latin typeface="Calibri" pitchFamily="34" charset="0"/>
-                <a:ea typeface="Calibri" pitchFamily="34" charset="-122"/>
-                <a:cs typeface="Calibri" pitchFamily="34" charset="-120"/>
-              </a:rPr>
-              <a:t>Re-arrange</a:t>
-            </a:r>
-            <a:endParaRPr lang="en-US" sz="1200" dirty="0"/>
-          </a:p>
-        </p:txBody>
-      </p:sp>
-      <p:sp>
-        <p:nvSpPr>
-          <p:cNvPr id="14" name="Text 12"/>
-          <p:cNvSpPr txBox="1"/>
-          <p:nvPr/>
-        </p:nvSpPr>
-        <p:spPr>
-          <a:xfrm>
-            <a:off x="969264" y="4151376"/>
-            <a:ext cx="5212080" cy="566928"/>
-          </a:xfrm>
-          <a:prstGeom prst="rect">
-            <a:avLst/>
-          </a:prstGeom>
-          <a:noFill/>
-          <a:ln/>
-        </p:spPr>
-        <p:txBody>
-          <a:bodyPr wrap="square" lIns="0" tIns="0" rIns="0" bIns="0" rtlCol="0" anchor="ctr"/>
-          <a:lstStyle/>
-          <a:p>
-            <a:pPr indent="0" marL="0">
-              <a:lnSpc>
-                <a:spcPts val="1400"/>
-              </a:lnSpc>
-              <a:buNone/>
-            </a:pPr>
-            <a:r>
-              <a:rPr lang="en-US" sz="1050" dirty="0">
-                <a:solidFill>
-                  <a:srgbClr val="5F5C55"/>
-                </a:solidFill>
-                <a:latin typeface="Calibri" pitchFamily="34" charset="0"/>
-                <a:ea typeface="Calibri" pitchFamily="34" charset="-122"/>
-                <a:cs typeface="Calibri" pitchFamily="34" charset="-120"/>
-              </a:rPr>
-              <a:t>The route is exported to the browser as a coefficient model, so a drag is arithmetic in the page — not a server round-trip.</a:t>
-            </a:r>
-            <a:endParaRPr lang="en-US" sz="1050" dirty="0"/>
-          </a:p>
-        </p:txBody>
-      </p:sp>
-      <p:sp>
-        <p:nvSpPr>
-          <p:cNvPr id="15" name="Text 13"/>
-          <p:cNvSpPr txBox="1"/>
-          <p:nvPr/>
-        </p:nvSpPr>
-        <p:spPr>
-          <a:xfrm>
-            <a:off x="566928" y="4937760"/>
-            <a:ext cx="274320" cy="274320"/>
-          </a:xfrm>
-          <a:prstGeom prst="ellipse">
-            <a:avLst/>
-          </a:prstGeom>
-          <a:solidFill>
-            <a:srgbClr val="1F6E9E"/>
-          </a:solidFill>
-          <a:ln/>
-        </p:spPr>
-        <p:txBody>
-          <a:bodyPr wrap="square" lIns="0" tIns="0" rIns="0" bIns="0" rtlCol="0" anchor="ctr"/>
-          <a:lstStyle/>
-          <a:p>
-            <a:pPr algn="ctr" indent="0" marL="0">
-              <a:buNone/>
-            </a:pPr>
-            <a:r>
-              <a:rPr lang="en-US" sz="1000" b="1" dirty="0">
-                <a:solidFill>
-                  <a:srgbClr val="FFFFFF"/>
-                </a:solidFill>
-                <a:latin typeface="Calibri" pitchFamily="34" charset="0"/>
-                <a:ea typeface="Calibri" pitchFamily="34" charset="-122"/>
-                <a:cs typeface="Calibri" pitchFamily="34" charset="-120"/>
-              </a:rPr>
-              <a:t>4</a:t>
-            </a:r>
-            <a:endParaRPr lang="en-US" sz="1000" dirty="0"/>
-          </a:p>
-        </p:txBody>
-      </p:sp>
-      <p:sp>
-        <p:nvSpPr>
-          <p:cNvPr id="16" name="Text 14"/>
-          <p:cNvSpPr txBox="1"/>
-          <p:nvPr/>
-        </p:nvSpPr>
-        <p:spPr>
-          <a:xfrm>
-            <a:off x="969264" y="4910328"/>
-            <a:ext cx="5212080" cy="219456"/>
-          </a:xfrm>
-          <a:prstGeom prst="rect">
-            <a:avLst/>
-          </a:prstGeom>
-          <a:noFill/>
-          <a:ln/>
-        </p:spPr>
-        <p:txBody>
-          <a:bodyPr wrap="square" lIns="0" tIns="0" rIns="0" bIns="0" rtlCol="0" anchor="ctr"/>
-          <a:lstStyle/>
-          <a:p>
-            <a:pPr indent="0" marL="0">
-              <a:buNone/>
-            </a:pPr>
-            <a:r>
-              <a:rPr lang="en-US" sz="1200" b="1" dirty="0">
-                <a:solidFill>
-                  <a:srgbClr val="1F1F1E"/>
-                </a:solidFill>
-                <a:latin typeface="Calibri" pitchFamily="34" charset="0"/>
-                <a:ea typeface="Calibri" pitchFamily="34" charset="-122"/>
-                <a:cs typeface="Calibri" pitchFamily="34" charset="-120"/>
-              </a:rPr>
-              <a:t>Decide</a:t>
-            </a:r>
-            <a:endParaRPr lang="en-US" sz="1200" dirty="0"/>
-          </a:p>
-        </p:txBody>
-      </p:sp>
-      <p:sp>
-        <p:nvSpPr>
-          <p:cNvPr id="17" name="Text 15"/>
-          <p:cNvSpPr txBox="1"/>
-          <p:nvPr/>
-        </p:nvSpPr>
-        <p:spPr>
-          <a:xfrm>
-            <a:off x="969264" y="5120640"/>
-            <a:ext cx="5212080" cy="566928"/>
-          </a:xfrm>
-          <a:prstGeom prst="rect">
-            <a:avLst/>
-          </a:prstGeom>
-          <a:noFill/>
-          <a:ln/>
-        </p:spPr>
-        <p:txBody>
-          <a:bodyPr wrap="square" lIns="0" tIns="0" rIns="0" bIns="0" rtlCol="0" anchor="ctr"/>
-          <a:lstStyle/>
-          <a:p>
-            <a:pPr indent="0" marL="0">
-              <a:lnSpc>
-                <a:spcPts val="1400"/>
-              </a:lnSpc>
-              <a:buNone/>
-            </a:pPr>
-            <a:r>
-              <a:rPr lang="en-US" sz="1050" dirty="0">
-                <a:solidFill>
-                  <a:srgbClr val="5F5C55"/>
-                </a:solidFill>
-                <a:latin typeface="Calibri" pitchFamily="34" charset="0"/>
-                <a:ea typeface="Calibri" pitchFamily="34" charset="-122"/>
-                <a:cs typeface="Calibri" pitchFamily="34" charset="-120"/>
-              </a:rPr>
-              <a:t>Four levers, a scenario comparison, and a feasibility-bounded optimiser over the same model.</a:t>
-            </a:r>
-            <a:endParaRPr lang="en-US" sz="1050" dirty="0"/>
-          </a:p>
-        </p:txBody>
-      </p:sp>
-      <p:sp>
-        <p:nvSpPr>
-          <p:cNvPr id="18" name="Shape 16"/>
+          <p:cNvPr id="6" name="Shape 4"/>
           <p:cNvSpPr/>
           <p:nvPr/>
         </p:nvSpPr>
         <p:spPr>
           <a:xfrm>
-            <a:off x="566928" y="5852160"/>
-            <a:ext cx="5623560" cy="658368"/>
+            <a:off x="566928" y="2011680"/>
+            <a:ext cx="5623560" cy="1115568"/>
           </a:xfrm>
           <a:prstGeom prst="roundRect">
             <a:avLst>
-              <a:gd name="adj" fmla="val 8333"/>
+              <a:gd name="adj" fmla="val 4918"/>
             </a:avLst>
           </a:prstGeom>
           <a:solidFill>
@@ -2814,14 +2326,14 @@
       </p:sp>
       <p:sp>
         <p:nvSpPr>
-          <p:cNvPr id="19" name="Text 17"/>
+          <p:cNvPr id="7" name="Text 5"/>
           <p:cNvSpPr txBox="1"/>
           <p:nvPr/>
         </p:nvSpPr>
         <p:spPr>
           <a:xfrm>
-            <a:off x="768096" y="5998464"/>
-            <a:ext cx="5257800" cy="402336"/>
+            <a:off x="786384" y="2194560"/>
+            <a:ext cx="5184648" cy="201168"/>
           </a:xfrm>
           <a:prstGeom prst="rect">
             <a:avLst/>
@@ -2837,37 +2349,553 @@
               <a:buNone/>
             </a:pPr>
             <a:r>
-              <a:rPr lang="en-US" sz="1100" b="1" dirty="0">
-                <a:solidFill>
-                  <a:srgbClr val="1F1F1E"/>
+              <a:rPr lang="en-US" sz="950" b="1" spc="140" kern="0" dirty="0">
+                <a:solidFill>
+                  <a:srgbClr val="B24A2C"/>
                 </a:solidFill>
                 <a:latin typeface="Calibri" pitchFamily="34" charset="0"/>
                 <a:ea typeface="Calibri" pitchFamily="34" charset="-122"/>
                 <a:cs typeface="Calibri" pitchFamily="34" charset="-120"/>
               </a:rPr>
-              <a:t>Four levers:  </a:t>
-            </a:r>
+              <a:t>WE WENT FURTHER THAN THE BRIEF</a:t>
+            </a:r>
+            <a:endParaRPr lang="en-US" sz="950" dirty="0"/>
+          </a:p>
+        </p:txBody>
+      </p:sp>
+      <p:sp>
+        <p:nvSpPr>
+          <p:cNvPr id="8" name="Text 6"/>
+          <p:cNvSpPr txBox="1"/>
+          <p:nvPr/>
+        </p:nvSpPr>
+        <p:spPr>
+          <a:xfrm>
+            <a:off x="786384" y="2450592"/>
+            <a:ext cx="5184648" cy="603504"/>
+          </a:xfrm>
+          <a:prstGeom prst="rect">
+            <a:avLst/>
+          </a:prstGeom>
+          <a:noFill/>
+          <a:ln/>
+        </p:spPr>
+        <p:txBody>
+          <a:bodyPr wrap="square" lIns="0" tIns="0" rIns="0" bIns="0" rtlCol="0" anchor="ctr"/>
+          <a:lstStyle/>
+          <a:p>
             <a:pPr indent="0" marL="0">
+              <a:lnSpc>
+                <a:spcPts val="1500"/>
+              </a:lnSpc>
               <a:buNone/>
             </a:pPr>
             <a:r>
               <a:rPr lang="en-US" sz="1100" dirty="0">
                 <a:solidFill>
-                  <a:srgbClr val="5F5C55"/>
+                  <a:srgbClr val="1F1F1E"/>
                 </a:solidFill>
                 <a:latin typeface="Calibri" pitchFamily="34" charset="0"/>
                 <a:ea typeface="Calibri" pitchFamily="34" charset="-122"/>
                 <a:cs typeface="Calibri" pitchFamily="34" charset="-120"/>
               </a:rPr>
-              <a:t>scrap share · grid mix · rail/road per leg · technology per stage</a:t>
+              <a:t>The brief asks for input mix and energy source. We modelled the process route as well — the technology a stage runs changes the tonne as much as the charge does, and nothing else lets a user see that.</a:t>
             </a:r>
             <a:endParaRPr lang="en-US" sz="1100" dirty="0"/>
+          </a:p>
+        </p:txBody>
+      </p:sp>
+      <p:sp>
+        <p:nvSpPr>
+          <p:cNvPr id="9" name="Text 7"/>
+          <p:cNvSpPr txBox="1"/>
+          <p:nvPr/>
+        </p:nvSpPr>
+        <p:spPr>
+          <a:xfrm>
+            <a:off x="566928" y="3310128"/>
+            <a:ext cx="274320" cy="274320"/>
+          </a:xfrm>
+          <a:prstGeom prst="ellipse">
+            <a:avLst/>
+          </a:prstGeom>
+          <a:solidFill>
+            <a:srgbClr val="1F6E9E"/>
+          </a:solidFill>
+          <a:ln/>
+        </p:spPr>
+        <p:txBody>
+          <a:bodyPr wrap="square" lIns="0" tIns="0" rIns="0" bIns="0" rtlCol="0" anchor="ctr"/>
+          <a:lstStyle/>
+          <a:p>
+            <a:pPr algn="ctr" indent="0" marL="0">
+              <a:buNone/>
+            </a:pPr>
+            <a:r>
+              <a:rPr lang="en-US" sz="1000" b="1" dirty="0">
+                <a:solidFill>
+                  <a:srgbClr val="FFFFFF"/>
+                </a:solidFill>
+                <a:latin typeface="Calibri" pitchFamily="34" charset="0"/>
+                <a:ea typeface="Calibri" pitchFamily="34" charset="-122"/>
+                <a:cs typeface="Calibri" pitchFamily="34" charset="-120"/>
+              </a:rPr>
+              <a:t>1</a:t>
+            </a:r>
+            <a:endParaRPr lang="en-US" sz="1000" dirty="0"/>
+          </a:p>
+        </p:txBody>
+      </p:sp>
+      <p:sp>
+        <p:nvSpPr>
+          <p:cNvPr id="10" name="Text 8"/>
+          <p:cNvSpPr txBox="1"/>
+          <p:nvPr/>
+        </p:nvSpPr>
+        <p:spPr>
+          <a:xfrm>
+            <a:off x="969264" y="3282696"/>
+            <a:ext cx="5221224" cy="219456"/>
+          </a:xfrm>
+          <a:prstGeom prst="rect">
+            <a:avLst/>
+          </a:prstGeom>
+          <a:noFill/>
+          <a:ln/>
+        </p:spPr>
+        <p:txBody>
+          <a:bodyPr wrap="square" lIns="0" tIns="0" rIns="0" bIns="0" rtlCol="0" anchor="ctr"/>
+          <a:lstStyle/>
+          <a:p>
+            <a:pPr indent="0" marL="0">
+              <a:buNone/>
+            </a:pPr>
+            <a:r>
+              <a:rPr lang="en-US" sz="1200" b="1" dirty="0">
+                <a:solidFill>
+                  <a:srgbClr val="1F1F1E"/>
+                </a:solidFill>
+                <a:latin typeface="Calibri" pitchFamily="34" charset="0"/>
+                <a:ea typeface="Calibri" pitchFamily="34" charset="-122"/>
+                <a:cs typeface="Calibri" pitchFamily="34" charset="-120"/>
+              </a:rPr>
+              <a:t>48 stages, on or off</a:t>
+            </a:r>
+            <a:endParaRPr lang="en-US" sz="1200" dirty="0"/>
+          </a:p>
+        </p:txBody>
+      </p:sp>
+      <p:sp>
+        <p:nvSpPr>
+          <p:cNvPr id="11" name="Text 9"/>
+          <p:cNvSpPr txBox="1"/>
+          <p:nvPr/>
+        </p:nvSpPr>
+        <p:spPr>
+          <a:xfrm>
+            <a:off x="969264" y="3502152"/>
+            <a:ext cx="5221224" cy="530352"/>
+          </a:xfrm>
+          <a:prstGeom prst="rect">
+            <a:avLst/>
+          </a:prstGeom>
+          <a:noFill/>
+          <a:ln/>
+        </p:spPr>
+        <p:txBody>
+          <a:bodyPr wrap="square" lIns="0" tIns="0" rIns="0" bIns="0" rtlCol="0" anchor="ctr"/>
+          <a:lstStyle/>
+          <a:p>
+            <a:pPr indent="0" marL="0">
+              <a:lnSpc>
+                <a:spcPts val="1400"/>
+              </a:lnSpc>
+              <a:buNone/>
+            </a:pPr>
+            <a:r>
+              <a:rPr lang="en-US" sz="1050" dirty="0">
+                <a:solidFill>
+                  <a:srgbClr val="5F5C55"/>
+                </a:solidFill>
+                <a:latin typeface="Calibri" pitchFamily="34" charset="0"/>
+                <a:ea typeface="Calibri" pitchFamily="34" charset="-122"/>
+                <a:cs typeface="Calibri" pitchFamily="34" charset="-120"/>
+              </a:rPr>
+              <a:t>Any step can be taken out of the route; the tonne recomputes without it.</a:t>
+            </a:r>
+            <a:endParaRPr lang="en-US" sz="1050" dirty="0"/>
+          </a:p>
+        </p:txBody>
+      </p:sp>
+      <p:sp>
+        <p:nvSpPr>
+          <p:cNvPr id="12" name="Text 10"/>
+          <p:cNvSpPr txBox="1"/>
+          <p:nvPr/>
+        </p:nvSpPr>
+        <p:spPr>
+          <a:xfrm>
+            <a:off x="566928" y="4059936"/>
+            <a:ext cx="274320" cy="274320"/>
+          </a:xfrm>
+          <a:prstGeom prst="ellipse">
+            <a:avLst/>
+          </a:prstGeom>
+          <a:solidFill>
+            <a:srgbClr val="1F6E9E"/>
+          </a:solidFill>
+          <a:ln/>
+        </p:spPr>
+        <p:txBody>
+          <a:bodyPr wrap="square" lIns="0" tIns="0" rIns="0" bIns="0" rtlCol="0" anchor="ctr"/>
+          <a:lstStyle/>
+          <a:p>
+            <a:pPr algn="ctr" indent="0" marL="0">
+              <a:buNone/>
+            </a:pPr>
+            <a:r>
+              <a:rPr lang="en-US" sz="1000" b="1" dirty="0">
+                <a:solidFill>
+                  <a:srgbClr val="FFFFFF"/>
+                </a:solidFill>
+                <a:latin typeface="Calibri" pitchFamily="34" charset="0"/>
+                <a:ea typeface="Calibri" pitchFamily="34" charset="-122"/>
+                <a:cs typeface="Calibri" pitchFamily="34" charset="-120"/>
+              </a:rPr>
+              <a:t>2</a:t>
+            </a:r>
+            <a:endParaRPr lang="en-US" sz="1000" dirty="0"/>
+          </a:p>
+        </p:txBody>
+      </p:sp>
+      <p:sp>
+        <p:nvSpPr>
+          <p:cNvPr id="13" name="Text 11"/>
+          <p:cNvSpPr txBox="1"/>
+          <p:nvPr/>
+        </p:nvSpPr>
+        <p:spPr>
+          <a:xfrm>
+            <a:off x="969264" y="4032504"/>
+            <a:ext cx="5221224" cy="219456"/>
+          </a:xfrm>
+          <a:prstGeom prst="rect">
+            <a:avLst/>
+          </a:prstGeom>
+          <a:noFill/>
+          <a:ln/>
+        </p:spPr>
+        <p:txBody>
+          <a:bodyPr wrap="square" lIns="0" tIns="0" rIns="0" bIns="0" rtlCol="0" anchor="ctr"/>
+          <a:lstStyle/>
+          <a:p>
+            <a:pPr indent="0" marL="0">
+              <a:buNone/>
+            </a:pPr>
+            <a:r>
+              <a:rPr lang="en-US" sz="1200" b="1" dirty="0">
+                <a:solidFill>
+                  <a:srgbClr val="1F1F1E"/>
+                </a:solidFill>
+                <a:latin typeface="Calibri" pitchFamily="34" charset="0"/>
+                <a:ea typeface="Calibri" pitchFamily="34" charset="-122"/>
+                <a:cs typeface="Calibri" pitchFamily="34" charset="-120"/>
+              </a:rPr>
+              <a:t>24 interchangeable technologies</a:t>
+            </a:r>
+            <a:endParaRPr lang="en-US" sz="1200" dirty="0"/>
+          </a:p>
+        </p:txBody>
+      </p:sp>
+      <p:sp>
+        <p:nvSpPr>
+          <p:cNvPr id="14" name="Text 12"/>
+          <p:cNvSpPr txBox="1"/>
+          <p:nvPr/>
+        </p:nvSpPr>
+        <p:spPr>
+          <a:xfrm>
+            <a:off x="969264" y="4251960"/>
+            <a:ext cx="5221224" cy="530352"/>
+          </a:xfrm>
+          <a:prstGeom prst="rect">
+            <a:avLst/>
+          </a:prstGeom>
+          <a:noFill/>
+          <a:ln/>
+        </p:spPr>
+        <p:txBody>
+          <a:bodyPr wrap="square" lIns="0" tIns="0" rIns="0" bIns="0" rtlCol="0" anchor="ctr"/>
+          <a:lstStyle/>
+          <a:p>
+            <a:pPr indent="0" marL="0">
+              <a:lnSpc>
+                <a:spcPts val="1400"/>
+              </a:lnSpc>
+              <a:buNone/>
+            </a:pPr>
+            <a:r>
+              <a:rPr lang="en-US" sz="1050" dirty="0">
+                <a:solidFill>
+                  <a:srgbClr val="5F5C55"/>
+                </a:solidFill>
+                <a:latin typeface="Calibri" pitchFamily="34" charset="0"/>
+                <a:ea typeface="Calibri" pitchFamily="34" charset="-122"/>
+                <a:cs typeface="Calibri" pitchFamily="34" charset="-120"/>
+              </a:rPr>
+              <a:t>Five stages carry real alternatives — 6 melting routes, 4 decarburisation, 4 refining, 8 casting, 2 inspection.</a:t>
+            </a:r>
+            <a:endParaRPr lang="en-US" sz="1050" dirty="0"/>
+          </a:p>
+        </p:txBody>
+      </p:sp>
+      <p:sp>
+        <p:nvSpPr>
+          <p:cNvPr id="15" name="Text 13"/>
+          <p:cNvSpPr txBox="1"/>
+          <p:nvPr/>
+        </p:nvSpPr>
+        <p:spPr>
+          <a:xfrm>
+            <a:off x="566928" y="4809744"/>
+            <a:ext cx="274320" cy="274320"/>
+          </a:xfrm>
+          <a:prstGeom prst="ellipse">
+            <a:avLst/>
+          </a:prstGeom>
+          <a:solidFill>
+            <a:srgbClr val="1F6E9E"/>
+          </a:solidFill>
+          <a:ln/>
+        </p:spPr>
+        <p:txBody>
+          <a:bodyPr wrap="square" lIns="0" tIns="0" rIns="0" bIns="0" rtlCol="0" anchor="ctr"/>
+          <a:lstStyle/>
+          <a:p>
+            <a:pPr algn="ctr" indent="0" marL="0">
+              <a:buNone/>
+            </a:pPr>
+            <a:r>
+              <a:rPr lang="en-US" sz="1000" b="1" dirty="0">
+                <a:solidFill>
+                  <a:srgbClr val="FFFFFF"/>
+                </a:solidFill>
+                <a:latin typeface="Calibri" pitchFamily="34" charset="0"/>
+                <a:ea typeface="Calibri" pitchFamily="34" charset="-122"/>
+                <a:cs typeface="Calibri" pitchFamily="34" charset="-120"/>
+              </a:rPr>
+              <a:t>3</a:t>
+            </a:r>
+            <a:endParaRPr lang="en-US" sz="1000" dirty="0"/>
+          </a:p>
+        </p:txBody>
+      </p:sp>
+      <p:sp>
+        <p:nvSpPr>
+          <p:cNvPr id="16" name="Text 14"/>
+          <p:cNvSpPr txBox="1"/>
+          <p:nvPr/>
+        </p:nvSpPr>
+        <p:spPr>
+          <a:xfrm>
+            <a:off x="969264" y="4782312"/>
+            <a:ext cx="5221224" cy="219456"/>
+          </a:xfrm>
+          <a:prstGeom prst="rect">
+            <a:avLst/>
+          </a:prstGeom>
+          <a:noFill/>
+          <a:ln/>
+        </p:spPr>
+        <p:txBody>
+          <a:bodyPr wrap="square" lIns="0" tIns="0" rIns="0" bIns="0" rtlCol="0" anchor="ctr"/>
+          <a:lstStyle/>
+          <a:p>
+            <a:pPr indent="0" marL="0">
+              <a:buNone/>
+            </a:pPr>
+            <a:r>
+              <a:rPr lang="en-US" sz="1200" b="1" dirty="0">
+                <a:solidFill>
+                  <a:srgbClr val="1F1F1E"/>
+                </a:solidFill>
+                <a:latin typeface="Calibri" pitchFamily="34" charset="0"/>
+                <a:ea typeface="Calibri" pitchFamily="34" charset="-122"/>
+                <a:cs typeface="Calibri" pitchFamily="34" charset="-120"/>
+              </a:rPr>
+              <a:t>Split a stage between two</a:t>
+            </a:r>
+            <a:endParaRPr lang="en-US" sz="1200" dirty="0"/>
+          </a:p>
+        </p:txBody>
+      </p:sp>
+      <p:sp>
+        <p:nvSpPr>
+          <p:cNvPr id="17" name="Text 15"/>
+          <p:cNvSpPr txBox="1"/>
+          <p:nvPr/>
+        </p:nvSpPr>
+        <p:spPr>
+          <a:xfrm>
+            <a:off x="969264" y="5001768"/>
+            <a:ext cx="5221224" cy="530352"/>
+          </a:xfrm>
+          <a:prstGeom prst="rect">
+            <a:avLst/>
+          </a:prstGeom>
+          <a:noFill/>
+          <a:ln/>
+        </p:spPr>
+        <p:txBody>
+          <a:bodyPr wrap="square" lIns="0" tIns="0" rIns="0" bIns="0" rtlCol="0" anchor="ctr"/>
+          <a:lstStyle/>
+          <a:p>
+            <a:pPr indent="0" marL="0">
+              <a:lnSpc>
+                <a:spcPts val="1400"/>
+              </a:lnSpc>
+              <a:buNone/>
+            </a:pPr>
+            <a:r>
+              <a:rPr lang="en-US" sz="1050" dirty="0">
+                <a:solidFill>
+                  <a:srgbClr val="5F5C55"/>
+                </a:solidFill>
+                <a:latin typeface="Calibri" pitchFamily="34" charset="0"/>
+                <a:ea typeface="Calibri" pitchFamily="34" charset="-122"/>
+                <a:cs typeface="Calibri" pitchFamily="34" charset="-120"/>
+              </a:rPr>
+              <a:t>Pick more than one and the tonne divides between them, the way a plant running two casters actually does.</a:t>
+            </a:r>
+            <a:endParaRPr lang="en-US" sz="1050" dirty="0"/>
+          </a:p>
+        </p:txBody>
+      </p:sp>
+      <p:sp>
+        <p:nvSpPr>
+          <p:cNvPr id="18" name="Text 16"/>
+          <p:cNvSpPr txBox="1"/>
+          <p:nvPr/>
+        </p:nvSpPr>
+        <p:spPr>
+          <a:xfrm>
+            <a:off x="566928" y="5559552"/>
+            <a:ext cx="274320" cy="274320"/>
+          </a:xfrm>
+          <a:prstGeom prst="ellipse">
+            <a:avLst/>
+          </a:prstGeom>
+          <a:solidFill>
+            <a:srgbClr val="1F6E9E"/>
+          </a:solidFill>
+          <a:ln/>
+        </p:spPr>
+        <p:txBody>
+          <a:bodyPr wrap="square" lIns="0" tIns="0" rIns="0" bIns="0" rtlCol="0" anchor="ctr"/>
+          <a:lstStyle/>
+          <a:p>
+            <a:pPr algn="ctr" indent="0" marL="0">
+              <a:buNone/>
+            </a:pPr>
+            <a:r>
+              <a:rPr lang="en-US" sz="1000" b="1" dirty="0">
+                <a:solidFill>
+                  <a:srgbClr val="FFFFFF"/>
+                </a:solidFill>
+                <a:latin typeface="Calibri" pitchFamily="34" charset="0"/>
+                <a:ea typeface="Calibri" pitchFamily="34" charset="-122"/>
+                <a:cs typeface="Calibri" pitchFamily="34" charset="-120"/>
+              </a:rPr>
+              <a:t>4</a:t>
+            </a:r>
+            <a:endParaRPr lang="en-US" sz="1000" dirty="0"/>
+          </a:p>
+        </p:txBody>
+      </p:sp>
+      <p:sp>
+        <p:nvSpPr>
+          <p:cNvPr id="19" name="Text 17"/>
+          <p:cNvSpPr txBox="1"/>
+          <p:nvPr/>
+        </p:nvSpPr>
+        <p:spPr>
+          <a:xfrm>
+            <a:off x="969264" y="5532120"/>
+            <a:ext cx="5221224" cy="219456"/>
+          </a:xfrm>
+          <a:prstGeom prst="rect">
+            <a:avLst/>
+          </a:prstGeom>
+          <a:noFill/>
+          <a:ln/>
+        </p:spPr>
+        <p:txBody>
+          <a:bodyPr wrap="square" lIns="0" tIns="0" rIns="0" bIns="0" rtlCol="0" anchor="ctr"/>
+          <a:lstStyle/>
+          <a:p>
+            <a:pPr indent="0" marL="0">
+              <a:buNone/>
+            </a:pPr>
+            <a:r>
+              <a:rPr lang="en-US" sz="1200" b="1" dirty="0">
+                <a:solidFill>
+                  <a:srgbClr val="1F1F1E"/>
+                </a:solidFill>
+                <a:latin typeface="Calibri" pitchFamily="34" charset="0"/>
+                <a:ea typeface="Calibri" pitchFamily="34" charset="-122"/>
+                <a:cs typeface="Calibri" pitchFamily="34" charset="-120"/>
+              </a:rPr>
+              <a:t>Live, mid-drag</a:t>
+            </a:r>
+            <a:endParaRPr lang="en-US" sz="1200" dirty="0"/>
+          </a:p>
+        </p:txBody>
+      </p:sp>
+      <p:sp>
+        <p:nvSpPr>
+          <p:cNvPr id="20" name="Text 18"/>
+          <p:cNvSpPr txBox="1"/>
+          <p:nvPr/>
+        </p:nvSpPr>
+        <p:spPr>
+          <a:xfrm>
+            <a:off x="969264" y="5751576"/>
+            <a:ext cx="5221224" cy="530352"/>
+          </a:xfrm>
+          <a:prstGeom prst="rect">
+            <a:avLst/>
+          </a:prstGeom>
+          <a:noFill/>
+          <a:ln/>
+        </p:spPr>
+        <p:txBody>
+          <a:bodyPr wrap="square" lIns="0" tIns="0" rIns="0" bIns="0" rtlCol="0" anchor="ctr"/>
+          <a:lstStyle/>
+          <a:p>
+            <a:pPr indent="0" marL="0">
+              <a:lnSpc>
+                <a:spcPts val="1400"/>
+              </a:lnSpc>
+              <a:buNone/>
+            </a:pPr>
+            <a:r>
+              <a:rPr lang="en-US" sz="1050" dirty="0">
+                <a:solidFill>
+                  <a:srgbClr val="5F5C55"/>
+                </a:solidFill>
+                <a:latin typeface="Calibri" pitchFamily="34" charset="0"/>
+                <a:ea typeface="Calibri" pitchFamily="34" charset="-122"/>
+                <a:cs typeface="Calibri" pitchFamily="34" charset="-120"/>
+              </a:rPr>
+              <a:t>The route is re-arranged into coefficients and evaluated in the browser, so figures and charts move with the slider — exact to 1×10⁻⁹.</a:t>
+            </a:r>
+            <a:endParaRPr lang="en-US" sz="1050" dirty="0"/>
           </a:p>
         </p:txBody>
       </p:sp>
       <p:pic>
         <p:nvPicPr>
-          <p:cNvPr id="20" name="Image 0" descr="shots/sc_readout.png">    </p:cNvPr>
+          <p:cNvPr id="21" name="Image 0" descr="shots/s3_readout.png">    </p:cNvPr>
           <p:cNvPicPr>
             <a:picLocks noChangeAspect="1"/>
           </p:cNvPicPr>
@@ -2891,7 +2919,7 @@
       </p:pic>
       <p:pic>
         <p:nvPicPr>
-          <p:cNvPr id="21" name="Image 1" descr="shots/sc_inputs.png">    </p:cNvPr>
+          <p:cNvPr id="22" name="Image 1" descr="shots/s3_grid.png">    </p:cNvPr>
           <p:cNvPicPr>
             <a:picLocks noChangeAspect="1"/>
           </p:cNvPicPr>
@@ -2905,8 +2933,8 @@
         </p:blipFill>
         <p:spPr>
           <a:xfrm>
-            <a:off x="6473952" y="1993392"/>
-            <a:ext cx="2971800" cy="3822192"/>
+            <a:off x="6473952" y="2066544"/>
+            <a:ext cx="5148072" cy="1755648"/>
           </a:xfrm>
           <a:prstGeom prst="rect">
             <a:avLst/>
@@ -2915,18 +2943,57 @@
       </p:pic>
       <p:sp>
         <p:nvSpPr>
-          <p:cNvPr id="22" name="Shape 18"/>
+          <p:cNvPr id="23" name="Text 19"/>
+          <p:cNvSpPr txBox="1"/>
+          <p:nvPr/>
+        </p:nvSpPr>
+        <p:spPr>
+          <a:xfrm>
+            <a:off x="6473952" y="3895344"/>
+            <a:ext cx="5148072" cy="219456"/>
+          </a:xfrm>
+          <a:prstGeom prst="rect">
+            <a:avLst/>
+          </a:prstGeom>
+          <a:noFill/>
+          <a:ln/>
+        </p:spPr>
+        <p:txBody>
+          <a:bodyPr wrap="square" lIns="0" tIns="0" rIns="0" bIns="0" rtlCol="0" anchor="ctr"/>
+          <a:lstStyle/>
+          <a:p>
+            <a:pPr indent="0" marL="0">
+              <a:buNone/>
+            </a:pPr>
+            <a:r>
+              <a:rPr lang="en-US" sz="1000" i="1" dirty="0">
+                <a:solidFill>
+                  <a:srgbClr val="5F5C55"/>
+                </a:solidFill>
+                <a:latin typeface="Calibri" pitchFamily="34" charset="0"/>
+                <a:ea typeface="Calibri" pitchFamily="34" charset="-122"/>
+                <a:cs typeface="Calibri" pitchFamily="34" charset="-120"/>
+              </a:rPr>
+              <a:t>Every row of the result carries its variation and its share of the stage.</a:t>
+            </a:r>
+            <a:endParaRPr lang="en-US" sz="1000" dirty="0"/>
+          </a:p>
+        </p:txBody>
+      </p:sp>
+      <p:sp>
+        <p:nvSpPr>
+          <p:cNvPr id="24" name="Shape 20"/>
           <p:cNvSpPr/>
           <p:nvPr/>
         </p:nvSpPr>
         <p:spPr>
           <a:xfrm>
-            <a:off x="9628632" y="1993392"/>
-            <a:ext cx="1993392" cy="3822192"/>
+            <a:off x="6473952" y="4279392"/>
+            <a:ext cx="5148072" cy="1719072"/>
           </a:xfrm>
           <a:prstGeom prst="roundRect">
             <a:avLst>
-              <a:gd name="adj" fmla="val 2752"/>
+              <a:gd name="adj" fmla="val 3191"/>
             </a:avLst>
           </a:prstGeom>
           <a:solidFill>
@@ -2942,14 +3009,14 @@
       </p:sp>
       <p:sp>
         <p:nvSpPr>
-          <p:cNvPr id="23" name="Text 19"/>
+          <p:cNvPr id="25" name="Text 21"/>
           <p:cNvSpPr txBox="1"/>
           <p:nvPr/>
         </p:nvSpPr>
         <p:spPr>
           <a:xfrm>
-            <a:off x="9829800" y="2212848"/>
-            <a:ext cx="1609344" cy="219456"/>
+            <a:off x="6729984" y="4572000"/>
+            <a:ext cx="1517904" cy="475488"/>
           </a:xfrm>
           <a:prstGeom prst="rect">
             <a:avLst/>
@@ -2965,30 +3032,72 @@
               <a:buNone/>
             </a:pPr>
             <a:r>
-              <a:rPr lang="en-US" sz="900" b="1" spc="120" kern="0" dirty="0">
+              <a:rPr lang="en-US" sz="2800" dirty="0">
                 <a:solidFill>
                   <a:srgbClr val="B24A2C"/>
+                </a:solidFill>
+                <a:latin typeface="Cambria" pitchFamily="34" charset="0"/>
+                <a:ea typeface="Cambria" pitchFamily="34" charset="-122"/>
+                <a:cs typeface="Cambria" pitchFamily="34" charset="-120"/>
+              </a:rPr>
+              <a:t>8</a:t>
+            </a:r>
+            <a:endParaRPr lang="en-US" sz="2800" dirty="0"/>
+          </a:p>
+        </p:txBody>
+      </p:sp>
+      <p:sp>
+        <p:nvSpPr>
+          <p:cNvPr id="26" name="Text 22"/>
+          <p:cNvSpPr txBox="1"/>
+          <p:nvPr/>
+        </p:nvSpPr>
+        <p:spPr>
+          <a:xfrm>
+            <a:off x="6729984" y="5084064"/>
+            <a:ext cx="1517904" cy="877824"/>
+          </a:xfrm>
+          <a:prstGeom prst="rect">
+            <a:avLst/>
+          </a:prstGeom>
+          <a:noFill/>
+          <a:ln/>
+        </p:spPr>
+        <p:txBody>
+          <a:bodyPr wrap="square" lIns="0" tIns="0" rIns="0" bIns="0" rtlCol="0" anchor="ctr"/>
+          <a:lstStyle/>
+          <a:p>
+            <a:pPr indent="0" marL="0">
+              <a:lnSpc>
+                <a:spcPts val="1200"/>
+              </a:lnSpc>
+              <a:buNone/>
+            </a:pPr>
+            <a:r>
+              <a:rPr lang="en-US" sz="950" dirty="0">
+                <a:solidFill>
+                  <a:srgbClr val="5F5C55"/>
                 </a:solidFill>
                 <a:latin typeface="Calibri" pitchFamily="34" charset="0"/>
                 <a:ea typeface="Calibri" pitchFamily="34" charset="-122"/>
                 <a:cs typeface="Calibri" pitchFamily="34" charset="-120"/>
               </a:rPr>
-              <a:t>WHAT THE USER SEES</a:t>
-            </a:r>
-            <a:endParaRPr lang="en-US" sz="900" dirty="0"/>
-          </a:p>
-        </p:txBody>
-      </p:sp>
-      <p:sp>
-        <p:nvSpPr>
-          <p:cNvPr id="24" name="Text 20"/>
+              <a:t>departments, raw material to despatch</a:t>
+            </a:r>
+            <a:endParaRPr lang="en-US" sz="950" dirty="0"/>
+          </a:p>
+        </p:txBody>
+      </p:sp>
+      <p:sp>
+        <p:nvSpPr>
+          <p:cNvPr id="27" name="Text 23"/>
           <p:cNvSpPr txBox="1"/>
           <p:nvPr/>
         </p:nvSpPr>
         <p:spPr>
           <a:xfrm>
-            <a:off x="9829800" y="2542032"/>
-            <a:ext cx="1609344" cy="3108960"/>
+            <a:off x="8375904" y="4572000"/>
+            <a:ext cx="1517904" cy="475488"/>
           </a:xfrm>
           <a:prstGeom prst="rect">
             <a:avLst/>
@@ -3000,15 +3109,50 @@
           <a:bodyPr wrap="square" lIns="0" tIns="0" rIns="0" bIns="0" rtlCol="0" anchor="ctr"/>
           <a:lstStyle/>
           <a:p>
-            <a:pPr marL="342900" indent="-342900">
+            <a:pPr indent="0" marL="0">
+              <a:buNone/>
+            </a:pPr>
+            <a:r>
+              <a:rPr lang="en-US" sz="2800" dirty="0">
+                <a:solidFill>
+                  <a:srgbClr val="B24A2C"/>
+                </a:solidFill>
+                <a:latin typeface="Cambria" pitchFamily="34" charset="0"/>
+                <a:ea typeface="Cambria" pitchFamily="34" charset="-122"/>
+                <a:cs typeface="Cambria" pitchFamily="34" charset="-120"/>
+              </a:rPr>
+              <a:t>48</a:t>
+            </a:r>
+            <a:endParaRPr lang="en-US" sz="2800" dirty="0"/>
+          </a:p>
+        </p:txBody>
+      </p:sp>
+      <p:sp>
+        <p:nvSpPr>
+          <p:cNvPr id="28" name="Text 24"/>
+          <p:cNvSpPr txBox="1"/>
+          <p:nvPr/>
+        </p:nvSpPr>
+        <p:spPr>
+          <a:xfrm>
+            <a:off x="8375904" y="5084064"/>
+            <a:ext cx="1517904" cy="877824"/>
+          </a:xfrm>
+          <a:prstGeom prst="rect">
+            <a:avLst/>
+          </a:prstGeom>
+          <a:noFill/>
+          <a:ln/>
+        </p:spPr>
+        <p:txBody>
+          <a:bodyPr wrap="square" lIns="0" tIns="0" rIns="0" bIns="0" rtlCol="0" anchor="ctr"/>
+          <a:lstStyle/>
+          <a:p>
+            <a:pPr indent="0" marL="0">
               <a:lnSpc>
-                <a:spcPts val="1250"/>
+                <a:spcPts val="1200"/>
               </a:lnSpc>
-              <a:spcAft>
-                <a:spcPts val="1000"/>
-              </a:spcAft>
-              <a:buSzPct val="100000"/>
-              <a:buChar char="•"/>
+              <a:buNone/>
             </a:pPr>
             <a:r>
               <a:rPr lang="en-US" sz="950" dirty="0">
@@ -3019,20 +3163,77 @@
                 <a:ea typeface="Calibri" pitchFamily="34" charset="-122"/>
                 <a:cs typeface="Calibri" pitchFamily="34" charset="-120"/>
               </a:rPr>
-              <a:t>One headline tonne, split into Scope 1 / 2 / 3</a:t>
+              <a:t>process stages, each switchable</a:t>
             </a:r>
             <a:endParaRPr lang="en-US" sz="950" dirty="0"/>
           </a:p>
-          <a:p>
-            <a:pPr marL="342900" indent="-342900">
+        </p:txBody>
+      </p:sp>
+      <p:sp>
+        <p:nvSpPr>
+          <p:cNvPr id="29" name="Text 25"/>
+          <p:cNvSpPr txBox="1"/>
+          <p:nvPr/>
+        </p:nvSpPr>
+        <p:spPr>
+          <a:xfrm>
+            <a:off x="10021824" y="4572000"/>
+            <a:ext cx="1517904" cy="475488"/>
+          </a:xfrm>
+          <a:prstGeom prst="rect">
+            <a:avLst/>
+          </a:prstGeom>
+          <a:noFill/>
+          <a:ln/>
+        </p:spPr>
+        <p:txBody>
+          <a:bodyPr wrap="square" lIns="0" tIns="0" rIns="0" bIns="0" rtlCol="0" anchor="ctr"/>
+          <a:lstStyle/>
+          <a:p>
+            <a:pPr indent="0" marL="0">
+              <a:buNone/>
+            </a:pPr>
+            <a:r>
+              <a:rPr lang="en-US" sz="2800" dirty="0">
+                <a:solidFill>
+                  <a:srgbClr val="B24A2C"/>
+                </a:solidFill>
+                <a:latin typeface="Cambria" pitchFamily="34" charset="0"/>
+                <a:ea typeface="Cambria" pitchFamily="34" charset="-122"/>
+                <a:cs typeface="Cambria" pitchFamily="34" charset="-120"/>
+              </a:rPr>
+              <a:t>24</a:t>
+            </a:r>
+            <a:endParaRPr lang="en-US" sz="2800" dirty="0"/>
+          </a:p>
+        </p:txBody>
+      </p:sp>
+      <p:sp>
+        <p:nvSpPr>
+          <p:cNvPr id="30" name="Text 26"/>
+          <p:cNvSpPr txBox="1"/>
+          <p:nvPr/>
+        </p:nvSpPr>
+        <p:spPr>
+          <a:xfrm>
+            <a:off x="10021824" y="5084064"/>
+            <a:ext cx="1517904" cy="877824"/>
+          </a:xfrm>
+          <a:prstGeom prst="rect">
+            <a:avLst/>
+          </a:prstGeom>
+          <a:noFill/>
+          <a:ln/>
+        </p:spPr>
+        <p:txBody>
+          <a:bodyPr wrap="square" lIns="0" tIns="0" rIns="0" bIns="0" rtlCol="0" anchor="ctr"/>
+          <a:lstStyle/>
+          <a:p>
+            <a:pPr indent="0" marL="0">
               <a:lnSpc>
-                <a:spcPts val="1250"/>
+                <a:spcPts val="1200"/>
               </a:lnSpc>
-              <a:spcAft>
-                <a:spcPts val="1000"/>
-              </a:spcAft>
-              <a:buSzPct val="100000"/>
-              <a:buChar char="•"/>
+              <a:buNone/>
             </a:pPr>
             <a:r>
               <a:rPr lang="en-US" sz="950" dirty="0">
@@ -3043,55 +3244,7 @@
                 <a:ea typeface="Calibri" pitchFamily="34" charset="-122"/>
                 <a:cs typeface="Calibri" pitchFamily="34" charset="-120"/>
               </a:rPr>
-              <a:t>Inputs in a docked panel, never a page away</a:t>
-            </a:r>
-            <a:endParaRPr lang="en-US" sz="950" dirty="0"/>
-          </a:p>
-          <a:p>
-            <a:pPr marL="342900" indent="-342900">
-              <a:lnSpc>
-                <a:spcPts val="1250"/>
-              </a:lnSpc>
-              <a:spcAft>
-                <a:spcPts val="1000"/>
-              </a:spcAft>
-              <a:buSzPct val="100000"/>
-              <a:buChar char="•"/>
-            </a:pPr>
-            <a:r>
-              <a:rPr lang="en-US" sz="950" dirty="0">
-                <a:solidFill>
-                  <a:srgbClr val="5F5C55"/>
-                </a:solidFill>
-                <a:latin typeface="Calibri" pitchFamily="34" charset="0"/>
-                <a:ea typeface="Calibri" pitchFamily="34" charset="-122"/>
-                <a:cs typeface="Calibri" pitchFamily="34" charset="-120"/>
-              </a:rPr>
-              <a:t>Figures and charts follow the slider live</a:t>
-            </a:r>
-            <a:endParaRPr lang="en-US" sz="950" dirty="0"/>
-          </a:p>
-          <a:p>
-            <a:pPr marL="342900" indent="-342900">
-              <a:lnSpc>
-                <a:spcPts val="1250"/>
-              </a:lnSpc>
-              <a:spcAft>
-                <a:spcPts val="1000"/>
-              </a:spcAft>
-              <a:buSzPct val="100000"/>
-              <a:buChar char="•"/>
-            </a:pPr>
-            <a:r>
-              <a:rPr lang="en-US" sz="950" dirty="0">
-                <a:solidFill>
-                  <a:srgbClr val="5F5C55"/>
-                </a:solidFill>
-                <a:latin typeface="Calibri" pitchFamily="34" charset="0"/>
-                <a:ea typeface="Calibri" pitchFamily="34" charset="-122"/>
-                <a:cs typeface="Calibri" pitchFamily="34" charset="-120"/>
-              </a:rPr>
-              <a:t>Per-process table behind every number</a:t>
+              <a:t>technologies across 5 decision points</a:t>
             </a:r>
             <a:endParaRPr lang="en-US" sz="950" dirty="0"/>
           </a:p>

</xml_diff>

<commit_message>
Put the brief's own two levers back at the centre of the deck
The objectives slide had drifted into describing the process-route work,
which is the addition, not the ask. It now leads with what the problem
statement names — scrap versus virgin charge and the energy mix — and
ends with the route as the one line beyond the brief.

The evidence table was quoted against a named site, so every figure in
it carried a plant identity. It is rebuilt against the workbook's own
default route, with a row for the charge lever acting alone (76% scrap,
grid and route untouched, -20.4%) before the optimiser levels. All of it
re-run from that reference, so the table, the screenshots and the impact
figures on the closing slide agree.

The Save-as placeholder in the tool named a site too; it now suggests a
configuration instead.

Co-Authored-By: Claude Opus 5 <noreply@anthropic.com>
Claude-Session: https://claude.ai/code/session_01X3GMZtjGyiho7SGyEY7pGJ
</commit_message>
<xml_diff>
--- a/CarbonSpark_PS3.pptx
+++ b/CarbonSpark_PS3.pptx
@@ -594,7 +594,7 @@
           <a:p>
             <a:r>
               <a:rPr lang="en-US" dirty="0"/>
-              <a:t>Open on the decision gap, not on the technology. The point of this slide: the emissions of a tonne are determined by four choices, and none of the people making them can see the consequence at the time. Numbers are from our own model run on the supplied workbook: the default route (40% scrap, today's Indian grid, first-listed technology at every stage) gives 6.167 tCO2e/t and 47.4 GJ/t. Scope 2 at 3.451 t/t is 56% of the total — say this out loud, it is the reason the grid-mix slider is the centrepiece of the tool. The objectives are deliberately measurable so the validation slide can be checked against them one by one.</a:t>
+              <a:t>Open on the decision gap, not on the technology. Keep the brief's own two levers front and centre — scrap versus virgin charge, and the energy mix — because those are what the problem statement asks for and what actually moves the tonne. The process-route work on the next slide is the cherry on top, not the headline; introduce it that way. Numbers are from our own model run on the supplied workbook: the default route (40% scrap, today's Indian grid, first-listed technology at every stage) gives 6.167 tCO2e/t and 47.4 GJ/t. Scope 2 at 3.451 t/t is 56% of the total — say this out loud, it is the reason the grid mix is the centrepiece of the tool. The objectives are deliberately measurable so the validation slide can be checked against them one by one.</a:t>
             </a:r>
             <a:endParaRPr lang="en-US" dirty="0"/>
           </a:p>
@@ -770,7 +770,7 @@
           <a:p>
             <a:r>
               <a:rPr lang="en-US" dirty="0"/>
-              <a:t>This is the evidence slide — spend the most time here. Every row is quoted against Jajpur as we model it (4.598 t/t), the same reference the tool uses on screen. The workbook's own default route sits 34% above it; Hisar is 1.5% above, so the two sites are close. Then the three optimiser levels. The key defence: 'Buildable today' at 2.089 t/t (-54.6%) holds coal at 45% or more of supply and caps hydro and nuclear near their real grid share, because an industrial consumer cannot contract unlimited amounts of either. That is what makes it a feasible answer rather than a hypothetical one. On validation, the strongest single fact is the 1e-9 agreement between the browser model and the server — the live figures are the same arithmetic, not an approximation. Be upfront about the limitations; the electricity intensities in the supplied workbook are high against public benchmarks, which is exactly why we present deltas rather than certified absolutes.</a:t>
+              <a:t>This is the evidence slide — spend the most time here. Every row is quoted against the workbook's own default route, 6.167 tCO2e/t, which is the same reference the tool shows on screen. Row two is worth pausing on: moving scrap alone from 40% to 76%, with the grid and the route untouched, already takes 20.4% off the tonne — that is the brief's first lever doing its work on its own. Then the three optimiser levels, which move the charge and the grid together. The key defence: 'Buildable today' at 3.498 t/t (-43.3%) holds coal at 45% or more of supply and caps hydro and nuclear near their real grid share, because an industrial consumer cannot contract unlimited amounts of either. That is what makes it a feasible answer rather than a hypothetical one. On validation, the strongest single fact is the 1e-9 agreement between the browser model and the server — the live figures are the same arithmetic, not an approximation. Be upfront about the limitations; the electricity intensities in the supplied workbook are high against public benchmarks, which is exactly why we present deltas rather than certified absolutes.</a:t>
             </a:r>
             <a:endParaRPr lang="en-US" dirty="0"/>
           </a:p>
@@ -858,7 +858,7 @@
           <a:p>
             <a:r>
               <a:rPr lang="en-US" dirty="0"/>
-              <a:t>Close on differentiation and impact. The one thing to say if you only get one sentence: every other calculator recomputes on the server after you let go of the control — ours re-arranges the model into coefficients and evaluates it in the page, so the number moves with your hand and is still exact to 1e-9. Second differentiator is the feasibility framing, which answers the brief's word 'practical' directly. On impact, quote the annualised figure: at 1 Mt of output, the buildable path avoids 2,508 kt CO2e a year, cuts specific energy 28.3%, and takes 65% off Scope 2 — the component that was 56% of the tonne on slide 1. Invite them to open the tool and change any input; nothing in it is hard-coded.</a:t>
+              <a:t>Close on differentiation and impact. The one thing to say if you only get one sentence: every other calculator recomputes on the server after you let go of the control — ours re-arranges the model into coefficients and evaluates it in the page, so the number moves with your hand and is still exact to 1e-9. Second differentiator is the feasibility framing, which answers the brief's word 'practical' directly. On impact, quote the annualised figure: at 1 Mt of output, the buildable path avoids 2,669 kt CO2e a year, cuts specific energy 18.8%, and takes 53.7% off Scope 2 — the component that was 56% of the tonne on slide 1. Invite them to open the tool and change any input; nothing in it is hard-coded.</a:t>
             </a:r>
             <a:endParaRPr lang="en-US" dirty="0"/>
           </a:p>
@@ -1604,8 +1604,8 @@
         </p:nvSpPr>
         <p:spPr>
           <a:xfrm>
-            <a:off x="566928" y="4553712"/>
-            <a:ext cx="6766560" cy="1737360"/>
+            <a:off x="566928" y="4645152"/>
+            <a:ext cx="6766560" cy="1645920"/>
           </a:xfrm>
           <a:prstGeom prst="rect">
             <a:avLst/>
@@ -1619,16 +1619,16 @@
           <a:p>
             <a:pPr marL="342900" indent="-342900">
               <a:lnSpc>
-                <a:spcPts val="1700"/>
+                <a:spcPts val="1500"/>
               </a:lnSpc>
               <a:spcAft>
-                <a:spcPts val="700"/>
+                <a:spcPts val="600"/>
               </a:spcAft>
               <a:buSzPct val="100000"/>
               <a:buChar char="•"/>
             </a:pPr>
             <a:r>
-              <a:rPr lang="en-US" sz="1250" dirty="0">
+              <a:rPr lang="en-US" sz="1150" dirty="0">
                 <a:solidFill>
                   <a:srgbClr val="5F5C55"/>
                 </a:solidFill>
@@ -1636,23 +1636,23 @@
                 <a:ea typeface="Calibri" pitchFamily="34" charset="-122"/>
                 <a:cs typeface="Calibri" pitchFamily="34" charset="-120"/>
               </a:rPr>
-              <a:t>Model every process step in the JSL grid — 67 routes across 8 departments — not a lumped plant average.</a:t>
-            </a:r>
-            <a:endParaRPr lang="en-US" sz="1250" dirty="0"/>
+              <a:t>Price the brief's two levers: scrap versus virgin charge, and the energy mix behind every kWh.</a:t>
+            </a:r>
+            <a:endParaRPr lang="en-US" sz="1150" dirty="0"/>
           </a:p>
           <a:p>
             <a:pPr marL="342900" indent="-342900">
               <a:lnSpc>
-                <a:spcPts val="1700"/>
+                <a:spcPts val="1500"/>
               </a:lnSpc>
               <a:spcAft>
-                <a:spcPts val="700"/>
+                <a:spcPts val="600"/>
               </a:spcAft>
               <a:buSzPct val="100000"/>
               <a:buChar char="•"/>
             </a:pPr>
             <a:r>
-              <a:rPr lang="en-US" sz="1250" dirty="0">
+              <a:rPr lang="en-US" sz="1150" dirty="0">
                 <a:solidFill>
                   <a:srgbClr val="5F5C55"/>
                 </a:solidFill>
@@ -1660,23 +1660,23 @@
                 <a:ea typeface="Calibri" pitchFamily="34" charset="-122"/>
                 <a:cs typeface="Calibri" pitchFamily="34" charset="-120"/>
               </a:rPr>
-              <a:t>Report Scope 1, 2 and 3 separately, per GHG Protocol, and reconcile to the workbook exactly.</a:t>
-            </a:r>
-            <a:endParaRPr lang="en-US" sz="1250" dirty="0"/>
+              <a:t>Report Scope 1, 2 and 3 separately and reconcile to the accounting grid exactly.</a:t>
+            </a:r>
+            <a:endParaRPr lang="en-US" sz="1150" dirty="0"/>
           </a:p>
           <a:p>
             <a:pPr marL="342900" indent="-342900">
               <a:lnSpc>
-                <a:spcPts val="1700"/>
+                <a:spcPts val="1500"/>
               </a:lnSpc>
               <a:spcAft>
-                <a:spcPts val="700"/>
+                <a:spcPts val="600"/>
               </a:spcAft>
               <a:buSzPct val="100000"/>
               <a:buChar char="•"/>
             </a:pPr>
             <a:r>
-              <a:rPr lang="en-US" sz="1250" dirty="0">
+              <a:rPr lang="en-US" sz="1150" dirty="0">
                 <a:solidFill>
                   <a:srgbClr val="5F5C55"/>
                 </a:solidFill>
@@ -1684,23 +1684,23 @@
                 <a:ea typeface="Calibri" pitchFamily="34" charset="-122"/>
                 <a:cs typeface="Calibri" pitchFamily="34" charset="-120"/>
               </a:rPr>
-              <a:t>Respond to an input while it is being dragged, not after it is released.</a:t>
-            </a:r>
-            <a:endParaRPr lang="en-US" sz="1250" dirty="0"/>
+              <a:t>Respond while the input is moving, not after it is released.</a:t>
+            </a:r>
+            <a:endParaRPr lang="en-US" sz="1150" dirty="0"/>
           </a:p>
           <a:p>
             <a:pPr marL="342900" indent="-342900">
               <a:lnSpc>
-                <a:spcPts val="1700"/>
+                <a:spcPts val="1500"/>
               </a:lnSpc>
               <a:spcAft>
-                <a:spcPts val="700"/>
+                <a:spcPts val="600"/>
               </a:spcAft>
               <a:buSzPct val="100000"/>
               <a:buChar char="•"/>
             </a:pPr>
             <a:r>
-              <a:rPr lang="en-US" sz="1250" dirty="0">
+              <a:rPr lang="en-US" sz="1150" dirty="0">
                 <a:solidFill>
                   <a:srgbClr val="5F5C55"/>
                 </a:solidFill>
@@ -1708,9 +1708,33 @@
                 <a:ea typeface="Calibri" pitchFamily="34" charset="-122"/>
                 <a:cs typeface="Calibri" pitchFamily="34" charset="-120"/>
               </a:rPr>
-              <a:t>Return a lower-carbon configuration the plant can actually contract — and say what it would take.</a:t>
-            </a:r>
-            <a:endParaRPr lang="en-US" sz="1250" dirty="0"/>
+              <a:t>Return a lower-carbon combination that is actually procurable.</a:t>
+            </a:r>
+            <a:endParaRPr lang="en-US" sz="1150" dirty="0"/>
+          </a:p>
+          <a:p>
+            <a:pPr marL="342900" indent="-342900">
+              <a:lnSpc>
+                <a:spcPts val="1500"/>
+              </a:lnSpc>
+              <a:spcAft>
+                <a:spcPts val="600"/>
+              </a:spcAft>
+              <a:buSzPct val="100000"/>
+              <a:buChar char="•"/>
+            </a:pPr>
+            <a:r>
+              <a:rPr lang="en-US" sz="1150" dirty="0">
+                <a:solidFill>
+                  <a:srgbClr val="5F5C55"/>
+                </a:solidFill>
+                <a:latin typeface="Calibri" pitchFamily="34" charset="0"/>
+                <a:ea typeface="Calibri" pitchFamily="34" charset="-122"/>
+                <a:cs typeface="Calibri" pitchFamily="34" charset="-120"/>
+              </a:rPr>
+              <a:t>Beyond the brief: make the process route editable too, priced the same way.</a:t>
+            </a:r>
+            <a:endParaRPr lang="en-US" sz="1150" dirty="0"/>
           </a:p>
         </p:txBody>
       </p:sp>
@@ -2263,8 +2287,8 @@
         </p:nvSpPr>
         <p:spPr>
           <a:xfrm>
-            <a:off x="566928" y="1316736"/>
-            <a:ext cx="5623560" cy="566928"/>
+            <a:off x="566928" y="1298448"/>
+            <a:ext cx="5623560" cy="731520"/>
           </a:xfrm>
           <a:prstGeom prst="rect">
             <a:avLst/>
@@ -3424,10 +3448,10 @@
             <a:tbl>
               <a:tblPr/>
               <a:tblGrid>
-                <a:gridCol w="2139696"/>
-                <a:gridCol w="859536"/>
-                <a:gridCol w="932688"/>
-                <a:gridCol w="2852928"/>
+                <a:gridCol w="2066544"/>
+                <a:gridCol w="841248"/>
+                <a:gridCol w="1042416"/>
+                <a:gridCol w="2834640"/>
               </a:tblGrid>
               <a:tr h="310896">
                 <a:tc>
@@ -3583,7 +3607,7 @@
                           <a:ea typeface="Calibri" pitchFamily="34" charset="-122"/>
                           <a:cs typeface="Calibri" pitchFamily="34" charset="-120"/>
                         </a:rPr>
-                        <a:t>vs JAJPUR</a:t>
+                        <a:t>vs DEFAULT</a:t>
                       </a:r>
                       <a:endParaRPr lang="en-US" sz="1050" dirty="0">
                         <a:latin typeface="Calibri" charset="0"/>
@@ -3721,7 +3745,7 @@
                           <a:ea typeface="Calibri" pitchFamily="34" charset="-122"/>
                           <a:cs typeface="Calibri" pitchFamily="34" charset="-120"/>
                         </a:rPr>
-                        <a:t>Workbook default route</a:t>
+                        <a:t>Default route — reference</a:t>
                       </a:r>
                       <a:endParaRPr lang="en-US" sz="1050" dirty="0">
                         <a:latin typeface="Calibri" charset="0"/>
@@ -3857,7 +3881,7 @@
                           <a:ea typeface="Calibri" pitchFamily="34" charset="-122"/>
                           <a:cs typeface="Calibri" pitchFamily="34" charset="-120"/>
                         </a:rPr>
-                        <a:t>+34.1%</a:t>
+                        <a:t>—</a:t>
                       </a:r>
                       <a:endParaRPr lang="en-US" sz="1050" dirty="0">
                         <a:latin typeface="Calibri" charset="0"/>
@@ -3925,7 +3949,7 @@
                           <a:ea typeface="Calibri" pitchFamily="34" charset="-122"/>
                           <a:cs typeface="Calibri" pitchFamily="34" charset="-120"/>
                         </a:rPr>
-                        <a:t>40% scrap · Indian grid today</a:t>
+                        <a:t>40% scrap · grid 0.712 · first-listed technology</a:t>
                       </a:r>
                       <a:endParaRPr lang="en-US" sz="950" dirty="0">
                         <a:latin typeface="Calibri" charset="0"/>
@@ -3995,7 +4019,7 @@
                           <a:ea typeface="Calibri" pitchFamily="34" charset="-122"/>
                           <a:cs typeface="Calibri" pitchFamily="34" charset="-120"/>
                         </a:rPr>
-                        <a:t>JSL Jajpur — reference</a:t>
+                        <a:t>Scrap alone, to 76%</a:t>
                       </a:r>
                       <a:endParaRPr lang="en-US" sz="1050" dirty="0">
                         <a:latin typeface="Calibri" charset="0"/>
@@ -4063,7 +4087,7 @@
                           <a:ea typeface="Calibri" pitchFamily="34" charset="-122"/>
                           <a:cs typeface="Calibri" pitchFamily="34" charset="-120"/>
                         </a:rPr>
-                        <a:t>4.598</a:t>
+                        <a:t>4.912</a:t>
                       </a:r>
                       <a:endParaRPr lang="en-US" sz="1050" dirty="0">
                         <a:latin typeface="Calibri" charset="0"/>
@@ -4131,7 +4155,7 @@
                           <a:ea typeface="Calibri" pitchFamily="34" charset="-122"/>
                           <a:cs typeface="Calibri" pitchFamily="34" charset="-120"/>
                         </a:rPr>
-                        <a:t>—</a:t>
+                        <a:t>−20.4%</a:t>
                       </a:r>
                       <a:endParaRPr lang="en-US" sz="1050" dirty="0">
                         <a:latin typeface="Calibri" charset="0"/>
@@ -4199,281 +4223,7 @@
                           <a:ea typeface="Calibri" pitchFamily="34" charset="-122"/>
                           <a:cs typeface="Calibri" pitchFamily="34" charset="-120"/>
                         </a:rPr>
-                        <a:t>35% scrap · 29 stages · 0.762 kg/kWh</a:t>
-                      </a:r>
-                      <a:endParaRPr lang="en-US" sz="950" dirty="0">
-                        <a:latin typeface="Calibri" charset="0"/>
-                        <a:ea typeface="Calibri" charset="0"/>
-                        <a:cs typeface="Calibri" charset="0"/>
-                      </a:endParaRPr>
-                    </a:p>
-                  </a:txBody>
-                  <a:tcPr marL="63500" marR="63500" marT="25400" marB="25400" anchor="ctr">
-                    <a:lnL w="6350" cap="flat" cmpd="sng" algn="ctr">
-                      <a:solidFill>
-                        <a:srgbClr val="DCD8CF"/>
-                      </a:solidFill>
-                      <a:prstDash val="solid"/>
-                      <a:round/>
-                      <a:headEnd type="none" w="med" len="med"/>
-                      <a:tailEnd type="none" w="med" len="med"/>
-                    </a:lnL>
-                    <a:lnR w="6350" cap="flat" cmpd="sng" algn="ctr">
-                      <a:solidFill>
-                        <a:srgbClr val="DCD8CF"/>
-                      </a:solidFill>
-                      <a:prstDash val="solid"/>
-                      <a:round/>
-                      <a:headEnd type="none" w="med" len="med"/>
-                      <a:tailEnd type="none" w="med" len="med"/>
-                    </a:lnR>
-                    <a:lnT w="6350" cap="flat" cmpd="sng" algn="ctr">
-                      <a:solidFill>
-                        <a:srgbClr val="DCD8CF"/>
-                      </a:solidFill>
-                      <a:prstDash val="solid"/>
-                      <a:round/>
-                      <a:headEnd type="none" w="med" len="med"/>
-                      <a:tailEnd type="none" w="med" len="med"/>
-                    </a:lnT>
-                    <a:lnB w="6350" cap="flat" cmpd="sng" algn="ctr">
-                      <a:solidFill>
-                        <a:srgbClr val="DCD8CF"/>
-                      </a:solidFill>
-                      <a:prstDash val="solid"/>
-                      <a:round/>
-                      <a:headEnd type="none" w="med" len="med"/>
-                      <a:tailEnd type="none" w="med" len="med"/>
-                    </a:lnB>
-                    <a:solidFill>
-                      <a:srgbClr val="FFFFFF"/>
-                    </a:solidFill>
-                  </a:tcPr>
-                </a:tc>
-              </a:tr>
-              <a:tr h="310896">
-                <a:tc>
-                  <a:txBody>
-                    <a:bodyPr/>
-                    <a:lstStyle/>
-                    <a:p>
-                      <a:pPr indent="0" marL="0">
-                        <a:buNone/>
-                      </a:pPr>
-                      <a:r>
-                        <a:rPr lang="en-US" sz="1050" dirty="0">
-                          <a:solidFill>
-                            <a:srgbClr val="1F1F1E"/>
-                          </a:solidFill>
-                          <a:latin typeface="Calibri" pitchFamily="34" charset="0"/>
-                          <a:ea typeface="Calibri" pitchFamily="34" charset="-122"/>
-                          <a:cs typeface="Calibri" pitchFamily="34" charset="-120"/>
-                        </a:rPr>
-                        <a:t>JSL Hisar as configured</a:t>
-                      </a:r>
-                      <a:endParaRPr lang="en-US" sz="1050" dirty="0">
-                        <a:latin typeface="Calibri" charset="0"/>
-                        <a:ea typeface="Calibri" charset="0"/>
-                        <a:cs typeface="Calibri" charset="0"/>
-                      </a:endParaRPr>
-                    </a:p>
-                  </a:txBody>
-                  <a:tcPr marL="63500" marR="63500" marT="25400" marB="25400" anchor="ctr">
-                    <a:lnL w="6350" cap="flat" cmpd="sng" algn="ctr">
-                      <a:solidFill>
-                        <a:srgbClr val="DCD8CF"/>
-                      </a:solidFill>
-                      <a:prstDash val="solid"/>
-                      <a:round/>
-                      <a:headEnd type="none" w="med" len="med"/>
-                      <a:tailEnd type="none" w="med" len="med"/>
-                    </a:lnL>
-                    <a:lnR w="6350" cap="flat" cmpd="sng" algn="ctr">
-                      <a:solidFill>
-                        <a:srgbClr val="DCD8CF"/>
-                      </a:solidFill>
-                      <a:prstDash val="solid"/>
-                      <a:round/>
-                      <a:headEnd type="none" w="med" len="med"/>
-                      <a:tailEnd type="none" w="med" len="med"/>
-                    </a:lnR>
-                    <a:lnT w="6350" cap="flat" cmpd="sng" algn="ctr">
-                      <a:solidFill>
-                        <a:srgbClr val="DCD8CF"/>
-                      </a:solidFill>
-                      <a:prstDash val="solid"/>
-                      <a:round/>
-                      <a:headEnd type="none" w="med" len="med"/>
-                      <a:tailEnd type="none" w="med" len="med"/>
-                    </a:lnT>
-                    <a:lnB w="6350" cap="flat" cmpd="sng" algn="ctr">
-                      <a:solidFill>
-                        <a:srgbClr val="DCD8CF"/>
-                      </a:solidFill>
-                      <a:prstDash val="solid"/>
-                      <a:round/>
-                      <a:headEnd type="none" w="med" len="med"/>
-                      <a:tailEnd type="none" w="med" len="med"/>
-                    </a:lnB>
-                    <a:solidFill>
-                      <a:srgbClr val="FFFFFF"/>
-                    </a:solidFill>
-                  </a:tcPr>
-                </a:tc>
-                <a:tc>
-                  <a:txBody>
-                    <a:bodyPr/>
-                    <a:lstStyle/>
-                    <a:p>
-                      <a:pPr algn="r" indent="0" marL="0">
-                        <a:buNone/>
-                      </a:pPr>
-                      <a:r>
-                        <a:rPr lang="en-US" sz="1050" dirty="0">
-                          <a:solidFill>
-                            <a:srgbClr val="1F1F1E"/>
-                          </a:solidFill>
-                          <a:latin typeface="Calibri" pitchFamily="34" charset="0"/>
-                          <a:ea typeface="Calibri" pitchFamily="34" charset="-122"/>
-                          <a:cs typeface="Calibri" pitchFamily="34" charset="-120"/>
-                        </a:rPr>
-                        <a:t>4.669</a:t>
-                      </a:r>
-                      <a:endParaRPr lang="en-US" sz="1050" dirty="0">
-                        <a:latin typeface="Calibri" charset="0"/>
-                        <a:ea typeface="Calibri" charset="0"/>
-                        <a:cs typeface="Calibri" charset="0"/>
-                      </a:endParaRPr>
-                    </a:p>
-                  </a:txBody>
-                  <a:tcPr marL="63500" marR="63500" marT="25400" marB="25400" anchor="ctr">
-                    <a:lnL w="6350" cap="flat" cmpd="sng" algn="ctr">
-                      <a:solidFill>
-                        <a:srgbClr val="DCD8CF"/>
-                      </a:solidFill>
-                      <a:prstDash val="solid"/>
-                      <a:round/>
-                      <a:headEnd type="none" w="med" len="med"/>
-                      <a:tailEnd type="none" w="med" len="med"/>
-                    </a:lnL>
-                    <a:lnR w="6350" cap="flat" cmpd="sng" algn="ctr">
-                      <a:solidFill>
-                        <a:srgbClr val="DCD8CF"/>
-                      </a:solidFill>
-                      <a:prstDash val="solid"/>
-                      <a:round/>
-                      <a:headEnd type="none" w="med" len="med"/>
-                      <a:tailEnd type="none" w="med" len="med"/>
-                    </a:lnR>
-                    <a:lnT w="6350" cap="flat" cmpd="sng" algn="ctr">
-                      <a:solidFill>
-                        <a:srgbClr val="DCD8CF"/>
-                      </a:solidFill>
-                      <a:prstDash val="solid"/>
-                      <a:round/>
-                      <a:headEnd type="none" w="med" len="med"/>
-                      <a:tailEnd type="none" w="med" len="med"/>
-                    </a:lnT>
-                    <a:lnB w="6350" cap="flat" cmpd="sng" algn="ctr">
-                      <a:solidFill>
-                        <a:srgbClr val="DCD8CF"/>
-                      </a:solidFill>
-                      <a:prstDash val="solid"/>
-                      <a:round/>
-                      <a:headEnd type="none" w="med" len="med"/>
-                      <a:tailEnd type="none" w="med" len="med"/>
-                    </a:lnB>
-                    <a:solidFill>
-                      <a:srgbClr val="FFFFFF"/>
-                    </a:solidFill>
-                  </a:tcPr>
-                </a:tc>
-                <a:tc>
-                  <a:txBody>
-                    <a:bodyPr/>
-                    <a:lstStyle/>
-                    <a:p>
-                      <a:pPr algn="r" indent="0" marL="0">
-                        <a:buNone/>
-                      </a:pPr>
-                      <a:r>
-                        <a:rPr lang="en-US" sz="1050" dirty="0">
-                          <a:solidFill>
-                            <a:srgbClr val="5F5C55"/>
-                          </a:solidFill>
-                          <a:latin typeface="Calibri" pitchFamily="34" charset="0"/>
-                          <a:ea typeface="Calibri" pitchFamily="34" charset="-122"/>
-                          <a:cs typeface="Calibri" pitchFamily="34" charset="-120"/>
-                        </a:rPr>
-                        <a:t>+1.5%</a:t>
-                      </a:r>
-                      <a:endParaRPr lang="en-US" sz="1050" dirty="0">
-                        <a:latin typeface="Calibri" charset="0"/>
-                        <a:ea typeface="Calibri" charset="0"/>
-                        <a:cs typeface="Calibri" charset="0"/>
-                      </a:endParaRPr>
-                    </a:p>
-                  </a:txBody>
-                  <a:tcPr marL="63500" marR="63500" marT="25400" marB="25400" anchor="ctr">
-                    <a:lnL w="6350" cap="flat" cmpd="sng" algn="ctr">
-                      <a:solidFill>
-                        <a:srgbClr val="DCD8CF"/>
-                      </a:solidFill>
-                      <a:prstDash val="solid"/>
-                      <a:round/>
-                      <a:headEnd type="none" w="med" len="med"/>
-                      <a:tailEnd type="none" w="med" len="med"/>
-                    </a:lnL>
-                    <a:lnR w="6350" cap="flat" cmpd="sng" algn="ctr">
-                      <a:solidFill>
-                        <a:srgbClr val="DCD8CF"/>
-                      </a:solidFill>
-                      <a:prstDash val="solid"/>
-                      <a:round/>
-                      <a:headEnd type="none" w="med" len="med"/>
-                      <a:tailEnd type="none" w="med" len="med"/>
-                    </a:lnR>
-                    <a:lnT w="6350" cap="flat" cmpd="sng" algn="ctr">
-                      <a:solidFill>
-                        <a:srgbClr val="DCD8CF"/>
-                      </a:solidFill>
-                      <a:prstDash val="solid"/>
-                      <a:round/>
-                      <a:headEnd type="none" w="med" len="med"/>
-                      <a:tailEnd type="none" w="med" len="med"/>
-                    </a:lnT>
-                    <a:lnB w="6350" cap="flat" cmpd="sng" algn="ctr">
-                      <a:solidFill>
-                        <a:srgbClr val="DCD8CF"/>
-                      </a:solidFill>
-                      <a:prstDash val="solid"/>
-                      <a:round/>
-                      <a:headEnd type="none" w="med" len="med"/>
-                      <a:tailEnd type="none" w="med" len="med"/>
-                    </a:lnB>
-                    <a:solidFill>
-                      <a:srgbClr val="FFFFFF"/>
-                    </a:solidFill>
-                  </a:tcPr>
-                </a:tc>
-                <a:tc>
-                  <a:txBody>
-                    <a:bodyPr/>
-                    <a:lstStyle/>
-                    <a:p>
-                      <a:pPr indent="0" marL="0">
-                        <a:buNone/>
-                      </a:pPr>
-                      <a:r>
-                        <a:rPr lang="en-US" sz="950" dirty="0">
-                          <a:solidFill>
-                            <a:srgbClr val="5F5C55"/>
-                          </a:solidFill>
-                          <a:latin typeface="Calibri" pitchFamily="34" charset="0"/>
-                          <a:ea typeface="Calibri" pitchFamily="34" charset="-122"/>
-                          <a:cs typeface="Calibri" pitchFamily="34" charset="-120"/>
-                        </a:rPr>
-                        <a:t>45% scrap · 31 stages</a:t>
+                        <a:t>same grid, same route — the charge lever on its own</a:t>
                       </a:r>
                       <a:endParaRPr lang="en-US" sz="950" dirty="0">
                         <a:latin typeface="Calibri" charset="0"/>
@@ -4611,7 +4361,7 @@
                           <a:ea typeface="Calibri" pitchFamily="34" charset="-122"/>
                           <a:cs typeface="Calibri" pitchFamily="34" charset="-120"/>
                         </a:rPr>
-                        <a:t>2.089</a:t>
+                        <a:t>3.498</a:t>
                       </a:r>
                       <a:endParaRPr lang="en-US" sz="1050" dirty="0">
                         <a:latin typeface="Calibri" charset="0"/>
@@ -4679,7 +4429,7 @@
                           <a:ea typeface="Calibri" pitchFamily="34" charset="-122"/>
                           <a:cs typeface="Calibri" pitchFamily="34" charset="-120"/>
                         </a:rPr>
-                        <a:t>−54.6%</a:t>
+                        <a:t>−43.3%</a:t>
                       </a:r>
                       <a:endParaRPr lang="en-US" sz="1050" dirty="0">
                         <a:latin typeface="Calibri" charset="0"/>
@@ -4885,7 +4635,7 @@
                           <a:ea typeface="Calibri" pitchFamily="34" charset="-122"/>
                           <a:cs typeface="Calibri" pitchFamily="34" charset="-120"/>
                         </a:rPr>
-                        <a:t>1.205</a:t>
+                        <a:t>2.057</a:t>
                       </a:r>
                       <a:endParaRPr lang="en-US" sz="1050" dirty="0">
                         <a:latin typeface="Calibri" charset="0"/>
@@ -4953,7 +4703,7 @@
                           <a:ea typeface="Calibri" pitchFamily="34" charset="-122"/>
                           <a:cs typeface="Calibri" pitchFamily="34" charset="-120"/>
                         </a:rPr>
-                        <a:t>−73.8%</a:t>
+                        <a:t>−66.7%</a:t>
                       </a:r>
                       <a:endParaRPr lang="en-US" sz="1050" dirty="0">
                         <a:latin typeface="Calibri" charset="0"/>
@@ -5159,7 +4909,7 @@
                           <a:ea typeface="Calibri" pitchFamily="34" charset="-122"/>
                           <a:cs typeface="Calibri" pitchFamily="34" charset="-120"/>
                         </a:rPr>
-                        <a:t>0.821</a:t>
+                        <a:t>1.498</a:t>
                       </a:r>
                       <a:endParaRPr lang="en-US" sz="1050" dirty="0">
                         <a:latin typeface="Calibri" charset="0"/>
@@ -5227,7 +4977,7 @@
                           <a:ea typeface="Calibri" pitchFamily="34" charset="-122"/>
                           <a:cs typeface="Calibri" pitchFamily="34" charset="-120"/>
                         </a:rPr>
-                        <a:t>−82.2%</a:t>
+                        <a:t>−75.7%</a:t>
                       </a:r>
                       <a:endParaRPr lang="en-US" sz="1050" dirty="0">
                         <a:latin typeface="Calibri" charset="0"/>
@@ -5635,7 +5385,7 @@
                 <a:ea typeface="Calibri" pitchFamily="34" charset="-122"/>
                 <a:cs typeface="Calibri" pitchFamily="34" charset="-120"/>
               </a:rPr>
-              <a:t>Plant profiles are built from public disclosures, not an equipment inventory. Jajpur's source-wise grid split is an estimate.</a:t>
+              <a:t>Site profiles in the tool are built from public disclosures, not equipment inventories, and their source-wise grid splits are estimates.</a:t>
             </a:r>
             <a:endParaRPr lang="en-US" sz="1000" dirty="0"/>
           </a:p>
@@ -5643,7 +5393,7 @@
       </p:sp>
       <p:pic>
         <p:nvPicPr>
-          <p:cNvPr id="10" name="Image 0" descr="shots/sc_optimiser.png">    </p:cNvPr>
+          <p:cNvPr id="10" name="Image 0" descr="shots/s4_opt.png">    </p:cNvPr>
           <p:cNvPicPr>
             <a:picLocks noChangeAspect="1"/>
           </p:cNvPicPr>
@@ -5658,7 +5408,7 @@
         <p:spPr>
           <a:xfrm>
             <a:off x="7552944" y="1316736"/>
-            <a:ext cx="4069080" cy="1792224"/>
+            <a:ext cx="4069080" cy="1051560"/>
           </a:xfrm>
           <a:prstGeom prst="rect">
             <a:avLst/>
@@ -5673,12 +5423,12 @@
         </p:nvSpPr>
         <p:spPr>
           <a:xfrm>
-            <a:off x="7552944" y="3273552"/>
-            <a:ext cx="4069080" cy="2907792"/>
+            <a:off x="7552944" y="2560320"/>
+            <a:ext cx="4069080" cy="3218688"/>
           </a:xfrm>
           <a:prstGeom prst="roundRect">
             <a:avLst>
-              <a:gd name="adj" fmla="val 1887"/>
+              <a:gd name="adj" fmla="val 1705"/>
             </a:avLst>
           </a:prstGeom>
           <a:solidFill>
@@ -5700,7 +5450,7 @@
         </p:nvSpPr>
         <p:spPr>
           <a:xfrm>
-            <a:off x="7790688" y="3474720"/>
+            <a:off x="7790688" y="2761488"/>
             <a:ext cx="3593592" cy="201168"/>
           </a:xfrm>
           <a:prstGeom prst="rect">
@@ -5739,7 +5489,7 @@
         </p:nvSpPr>
         <p:spPr>
           <a:xfrm>
-            <a:off x="7790688" y="3730752"/>
+            <a:off x="7790688" y="3017520"/>
             <a:ext cx="3593592" cy="2286000"/>
           </a:xfrm>
           <a:prstGeom prst="rect">
@@ -5754,12 +5504,12 @@
           <a:p>
             <a:pPr indent="0" marL="0">
               <a:lnSpc>
-                <a:spcPts val="1400"/>
+                <a:spcPts val="1500"/>
               </a:lnSpc>
               <a:buNone/>
             </a:pPr>
             <a:r>
-              <a:rPr lang="en-US" sz="1000" dirty="0">
+              <a:rPr lang="en-US" sz="1050" dirty="0">
                 <a:solidFill>
                   <a:srgbClr val="5F5C55"/>
                 </a:solidFill>
@@ -5769,7 +5519,7 @@
               </a:rPr>
               <a:t>An unbounded search lands on 100% scrap and a 100% wind grid and tells the plant nothing. Each level carries its own explicit limits — a coal floor because the grid a plant is connected to is coal-fired, a scrap cap because stainless needs virgin chromium and nickel, and no vacuum or remelting routes, which carry a negligible share of world tonnage. The tool states the reasoning for every limit on screen.</a:t>
             </a:r>
-            <a:endParaRPr lang="en-US" sz="1000" dirty="0"/>
+            <a:endParaRPr lang="en-US" sz="1050" dirty="0"/>
           </a:p>
         </p:txBody>
       </p:sp>
@@ -6250,7 +6000,7 @@
       </p:sp>
       <p:pic>
         <p:nvPicPr>
-          <p:cNvPr id="13" name="Image 0" descr="shots/sc_compare.png">    </p:cNvPr>
+          <p:cNvPr id="13" name="Image 0" descr="shots/s5_cmp.png">    </p:cNvPr>
           <p:cNvPicPr>
             <a:picLocks noChangeAspect="1"/>
           </p:cNvPicPr>
@@ -6371,7 +6121,7 @@
                 <a:ea typeface="Cambria" pitchFamily="34" charset="-122"/>
                 <a:cs typeface="Cambria" pitchFamily="34" charset="-120"/>
               </a:rPr>
-              <a:t>2,508</a:t>
+              <a:t>2,669</a:t>
             </a:r>
             <a:endParaRPr lang="en-US" sz="2200" dirty="0"/>
           </a:p>
@@ -6452,7 +6202,7 @@
                 <a:ea typeface="Cambria" pitchFamily="34" charset="-122"/>
                 <a:cs typeface="Cambria" pitchFamily="34" charset="-120"/>
               </a:rPr>
-              <a:t>−28.3%</a:t>
+              <a:t>−18.8%</a:t>
             </a:r>
             <a:endParaRPr lang="en-US" sz="2200" dirty="0"/>
           </a:p>
@@ -6494,7 +6244,7 @@
                 <a:ea typeface="Calibri" pitchFamily="34" charset="-122"/>
                 <a:cs typeface="Calibri" pitchFamily="34" charset="-120"/>
               </a:rPr>
-              <a:t>specific energy, 33.9 → 24.3 GJ/t</a:t>
+              <a:t>specific energy, 47.4 → 38.5 GJ/t</a:t>
             </a:r>
             <a:endParaRPr lang="en-US" sz="850" dirty="0"/>
           </a:p>
@@ -6533,7 +6283,7 @@
                 <a:ea typeface="Cambria" pitchFamily="34" charset="-122"/>
                 <a:cs typeface="Cambria" pitchFamily="34" charset="-120"/>
               </a:rPr>
-              <a:t>−65.0%</a:t>
+              <a:t>−53.7%</a:t>
             </a:r>
             <a:endParaRPr lang="en-US" sz="2200" dirty="0"/>
           </a:p>

</xml_diff>